<commit_message>
Apply 1-year car rental (50/month, no deposit, single car) to plan v11, approval docx and attachment
Co-Authored-By: Claude Opus 5.5 <noreply@anthropic.com>
Claude-Session: https://claude.ai/code/session_01SrTScNKmsHS34birk48N5j
</commit_message>
<xml_diff>
--- a/output/changwon_budget_request_attachment.pptx
+++ b/output/changwon_budget_request_attachment.pptx
@@ -1574,7 +1574,7 @@
                 <a:ea typeface="Noto Sans KR" pitchFamily="34" charset="-122"/>
                 <a:cs typeface="Noto Sans KR" pitchFamily="34" charset="-120"/>
               </a:rPr>
-              <a:t>2026 개설 집행 2,863만 원 · 2027 운영 예산 7,447만 원 · 보증금 6,252만 원(반환)</a:t>
+              <a:t>2026 개설 집행 2,891만 원 · 2027 운영 예산 6,823만 원 · 보증금 5,352만 원(반환)</a:t>
             </a:r>
             <a:endParaRPr lang="en-US" sz="1950" dirty="0"/>
           </a:p>
@@ -4003,7 +4003,7 @@
                           <a:ea typeface="Noto Sans KR" pitchFamily="34" charset="-122"/>
                           <a:cs typeface="Noto Sans KR" pitchFamily="34" charset="-120"/>
                         </a:rPr>
-                        <a:t>132</a:t>
+                        <a:t>160</a:t>
                       </a:r>
                       <a:endParaRPr lang="en-US" sz="1050" dirty="0">
                         <a:latin typeface="Noto Sans KR" charset="0"/>
@@ -4071,7 +4071,7 @@
                           <a:ea typeface="Noto Sans KR" pitchFamily="34" charset="-122"/>
                           <a:cs typeface="Noto Sans KR" pitchFamily="34" charset="-120"/>
                         </a:rPr>
-                        <a:t>1,584</a:t>
+                        <a:t>960</a:t>
                       </a:r>
                       <a:endParaRPr lang="en-US" sz="1050" dirty="0">
                         <a:latin typeface="Noto Sans KR" charset="0"/>
@@ -4139,7 +4139,7 @@
                           <a:ea typeface="Noto Sans KR" pitchFamily="34" charset="-122"/>
                           <a:cs typeface="Noto Sans KR" pitchFamily="34" charset="-120"/>
                         </a:rPr>
-                        <a:t>1대 → 2대</a:t>
+                        <a:t>1년 렌트 월 50 + 운영 30 · 1대</a:t>
                       </a:r>
                       <a:endParaRPr lang="en-US" sz="1050" dirty="0">
                         <a:latin typeface="Noto Sans KR" charset="0"/>
@@ -4687,7 +4687,7 @@
                           <a:ea typeface="Noto Sans KR" pitchFamily="34" charset="-122"/>
                           <a:cs typeface="Noto Sans KR" pitchFamily="34" charset="-120"/>
                         </a:rPr>
-                        <a:t>2,863</a:t>
+                        <a:t>2,891</a:t>
                       </a:r>
                       <a:endParaRPr lang="en-US" sz="1050" dirty="0">
                         <a:latin typeface="Noto Sans KR" charset="0"/>
@@ -4755,7 +4755,7 @@
                           <a:ea typeface="Noto Sans KR" pitchFamily="34" charset="-122"/>
                           <a:cs typeface="Noto Sans KR" pitchFamily="34" charset="-120"/>
                         </a:rPr>
-                        <a:t>7,447</a:t>
+                        <a:t>6,823</a:t>
                       </a:r>
                       <a:endParaRPr lang="en-US" sz="1050" dirty="0">
                         <a:latin typeface="Noto Sans KR" charset="0"/>
@@ -5371,7 +5371,7 @@
                           <a:ea typeface="Noto Sans KR" pitchFamily="34" charset="-122"/>
                           <a:cs typeface="Noto Sans KR" pitchFamily="34" charset="-120"/>
                         </a:rPr>
-                        <a:t>755</a:t>
+                        <a:t>783</a:t>
                       </a:r>
                       <a:endParaRPr lang="en-US" sz="1050" dirty="0">
                         <a:latin typeface="Noto Sans KR" charset="0"/>
@@ -5439,7 +5439,7 @@
                           <a:ea typeface="Noto Sans KR" pitchFamily="34" charset="-122"/>
                           <a:cs typeface="Noto Sans KR" pitchFamily="34" charset="-120"/>
                         </a:rPr>
-                        <a:t>5,469</a:t>
+                        <a:t>4,845</a:t>
                       </a:r>
                       <a:endParaRPr lang="en-US" sz="1050" dirty="0">
                         <a:latin typeface="Noto Sans KR" charset="0"/>
@@ -5713,7 +5713,7 @@
                           <a:ea typeface="Noto Sans KR" pitchFamily="34" charset="-122"/>
                           <a:cs typeface="Noto Sans KR" pitchFamily="34" charset="-120"/>
                         </a:rPr>
-                        <a:t>6,252</a:t>
+                        <a:t>5,352</a:t>
                       </a:r>
                       <a:endParaRPr lang="en-US" sz="1050" dirty="0">
                         <a:latin typeface="Noto Sans KR" charset="0"/>
@@ -5781,7 +5781,7 @@
                           <a:ea typeface="Noto Sans KR" pitchFamily="34" charset="-122"/>
                           <a:cs typeface="Noto Sans KR" pitchFamily="34" charset="-120"/>
                         </a:rPr>
-                        <a:t>900</a:t>
+                        <a:t>–</a:t>
                       </a:r>
                       <a:endParaRPr lang="en-US" sz="1050" dirty="0">
                         <a:latin typeface="Noto Sans KR" charset="0"/>
@@ -5849,7 +5849,7 @@
                           <a:ea typeface="Noto Sans KR" pitchFamily="34" charset="-122"/>
                           <a:cs typeface="Noto Sans KR" pitchFamily="34" charset="-120"/>
                         </a:rPr>
-                        <a:t>2027은 차량 1대 추가</a:t>
+                        <a:t>차량 렌트 보증금 없음</a:t>
                       </a:r>
                       <a:endParaRPr lang="en-US" sz="1050" dirty="0">
                         <a:latin typeface="Noto Sans KR" charset="0"/>
@@ -5949,7 +5949,7 @@
                 <a:ea typeface="Noto Sans KR" pitchFamily="34" charset="-122"/>
                 <a:cs typeface="Noto Sans KR" pitchFamily="34" charset="-120"/>
               </a:rPr>
-              <a:t>2026 집행 2,863만 원</a:t>
+              <a:t>2026 집행 2,891만 원</a:t>
             </a:r>
             <a:r>
               <a:rPr lang="en-US" sz="3150" b="1" kern="0" spc="-31" dirty="0">
@@ -5960,7 +5960,7 @@
                 <a:ea typeface="Noto Sans KR" pitchFamily="34" charset="-122"/>
                 <a:cs typeface="Noto Sans KR" pitchFamily="34" charset="-120"/>
               </a:rPr>
-              <a:t> · 2027 편성 7,447만 원</a:t>
+              <a:t> · 2027 편성 6,823만 원</a:t>
             </a:r>
             <a:endParaRPr lang="en-US" sz="3150" dirty="0"/>
           </a:p>
@@ -6276,7 +6276,7 @@
                 <a:latin typeface="Noto Sans KR"/>
                 <a:ea typeface="Noto Sans KR"/>
               </a:rPr>
-              <a:t>2,863</a:t>
+              <a:t>2,891</a:t>
             </a:r>
             <a:r>
               <a:rPr sz="1200" b="1">
@@ -6358,7 +6358,7 @@
                 <a:latin typeface="Noto Sans KR"/>
                 <a:ea typeface="Noto Sans KR"/>
               </a:rPr>
-              <a:t>일회성 1,943 + 운영 920</a:t>
+              <a:t>일회성 1,943 + 운영 948</a:t>
             </a:r>
           </a:p>
         </p:txBody>
@@ -6442,7 +6442,7 @@
                 <a:latin typeface="Noto Sans KR"/>
                 <a:ea typeface="Noto Sans KR"/>
               </a:rPr>
-              <a:t>6,252</a:t>
+              <a:t>5,352</a:t>
             </a:r>
             <a:r>
               <a:rPr sz="1200" b="1">
@@ -6524,7 +6524,7 @@
                 <a:latin typeface="Noto Sans KR"/>
                 <a:ea typeface="Noto Sans KR"/>
               </a:rPr>
-              <a:t>주거 5,000 · 사무실 352 · 차량 900</a:t>
+              <a:t>주거 5,000 · 사무실 352 · 차량 보증금 없음</a:t>
             </a:r>
           </a:p>
         </p:txBody>
@@ -6608,7 +6608,7 @@
                 <a:latin typeface="Noto Sans KR"/>
                 <a:ea typeface="Noto Sans KR"/>
               </a:rPr>
-              <a:t>7,447</a:t>
+              <a:t>6,823</a:t>
             </a:r>
             <a:r>
               <a:rPr sz="1200" b="1">
@@ -6690,7 +6690,7 @@
                 <a:latin typeface="Noto Sans KR"/>
                 <a:ea typeface="Noto Sans KR"/>
               </a:rPr>
-              <a:t>파견 2인 · 차량 2대 · 12개월</a:t>
+              <a:t>파견 2인 · 차량 1대 · 12개월</a:t>
             </a:r>
           </a:p>
         </p:txBody>
@@ -6774,7 +6774,7 @@
                 <a:latin typeface="Noto Sans KR"/>
                 <a:ea typeface="Noto Sans KR"/>
               </a:rPr>
-              <a:t>5,469</a:t>
+              <a:t>4,845</a:t>
             </a:r>
             <a:r>
               <a:rPr sz="1200" b="1">
@@ -7053,7 +7053,7 @@
                 <a:latin typeface="Noto Sans KR"/>
                 <a:ea typeface="Noto Sans KR"/>
               </a:rPr>
-              <a:t>— 2,863만 원 (일회성 1,943 + 11~12월 운영 920)</a:t>
+              <a:t>— 2,891만 원 (일회성 1,943 + 11~12월 운영 948)</a:t>
             </a:r>
           </a:p>
           <a:p>
@@ -7080,7 +7080,7 @@
                 <a:latin typeface="Noto Sans KR"/>
                 <a:ea typeface="Noto Sans KR"/>
               </a:rPr>
-              <a:t>— 6,252만 원, 반환 자산으로 계상 (주거 5,000 · 사무실 임대 208 · 관리비 예치 144 · 차량 ≤900)</a:t>
+              <a:t>— 5,352만 원, 반환 자산으로 계상 (주거 5,000 · 사무실 임대 208 · 관리비 예치 144)</a:t>
             </a:r>
           </a:p>
           <a:p>
@@ -7107,7 +7107,7 @@
                 <a:latin typeface="Noto Sans KR"/>
                 <a:ea typeface="Noto Sans KR"/>
               </a:rPr>
-              <a:t>— 연 7,447만 원, 출장비 절감 반영 순증 5,469만 원</a:t>
+              <a:t>— 연 6,823만 원, 출장비 절감 반영 순증 4,845만 원</a:t>
             </a:r>
           </a:p>
           <a:p>
@@ -19795,7 +19795,7 @@
                           <a:ea typeface="Noto Sans KR" pitchFamily="34" charset="-122"/>
                           <a:cs typeface="Noto Sans KR" pitchFamily="34" charset="-120"/>
                         </a:rPr>
-                        <a:t>36 / 대</a:t>
+                        <a:t>50</a:t>
                       </a:r>
                       <a:endParaRPr lang="en-US" sz="1050" dirty="0">
                         <a:latin typeface="Noto Sans KR" charset="0"/>
@@ -19863,7 +19863,7 @@
                           <a:ea typeface="Noto Sans KR" pitchFamily="34" charset="-122"/>
                           <a:cs typeface="Noto Sans KR" pitchFamily="34" charset="-120"/>
                         </a:rPr>
-                        <a:t>72.0</a:t>
+                        <a:t>100.0</a:t>
                       </a:r>
                       <a:endParaRPr lang="en-US" sz="1050" dirty="0">
                         <a:latin typeface="Noto Sans KR" charset="0"/>
@@ -19931,7 +19931,7 @@
                           <a:ea typeface="Noto Sans KR" pitchFamily="34" charset="-122"/>
                           <a:cs typeface="Noto Sans KR" pitchFamily="34" charset="-120"/>
                         </a:rPr>
-                        <a:t>864.0</a:t>
+                        <a:t>600.0</a:t>
                       </a:r>
                       <a:endParaRPr lang="en-US" sz="1050" dirty="0">
                         <a:latin typeface="Noto Sans KR" charset="0"/>
@@ -19999,7 +19999,7 @@
                           <a:ea typeface="Noto Sans KR" pitchFamily="34" charset="-122"/>
                           <a:cs typeface="Noto Sans KR" pitchFamily="34" charset="-120"/>
                         </a:rPr>
-                        <a:t>아반떼급 · 1→2대</a:t>
+                        <a:t>1년 계약 · 보증금 없음 · 1대</a:t>
                       </a:r>
                       <a:endParaRPr lang="en-US" sz="1050" dirty="0">
                         <a:latin typeface="Noto Sans KR" charset="0"/>
@@ -20137,7 +20137,7 @@
                           <a:ea typeface="Noto Sans KR" pitchFamily="34" charset="-122"/>
                           <a:cs typeface="Noto Sans KR" pitchFamily="34" charset="-120"/>
                         </a:rPr>
-                        <a:t>30 / 대</a:t>
+                        <a:t>30</a:t>
                       </a:r>
                       <a:endParaRPr lang="en-US" sz="1050" dirty="0">
                         <a:latin typeface="Noto Sans KR" charset="0"/>
@@ -20273,7 +20273,7 @@
                           <a:ea typeface="Noto Sans KR" pitchFamily="34" charset="-122"/>
                           <a:cs typeface="Noto Sans KR" pitchFamily="34" charset="-120"/>
                         </a:rPr>
-                        <a:t>720.0</a:t>
+                        <a:t>360.0</a:t>
                       </a:r>
                       <a:endParaRPr lang="en-US" sz="1050" dirty="0">
                         <a:latin typeface="Noto Sans KR" charset="0"/>
@@ -20341,7 +20341,7 @@
                           <a:ea typeface="Noto Sans KR" pitchFamily="34" charset="-122"/>
                           <a:cs typeface="Noto Sans KR" pitchFamily="34" charset="-120"/>
                         </a:rPr>
-                        <a:t>월 2,000km</a:t>
+                        <a:t>1대 · 월 2,000km</a:t>
                       </a:r>
                       <a:endParaRPr lang="en-US" sz="1050" dirty="0">
                         <a:latin typeface="Noto Sans KR" charset="0"/>
@@ -20889,7 +20889,7 @@
                           <a:ea typeface="Noto Sans KR" pitchFamily="34" charset="-122"/>
                           <a:cs typeface="Noto Sans KR" pitchFamily="34" charset="-120"/>
                         </a:rPr>
-                        <a:t>698.0</a:t>
+                        <a:t>726.0</a:t>
                       </a:r>
                       <a:endParaRPr lang="en-US" sz="1050" dirty="0">
                         <a:latin typeface="Noto Sans KR" charset="0"/>
@@ -20957,7 +20957,7 @@
                           <a:ea typeface="Noto Sans KR" pitchFamily="34" charset="-122"/>
                           <a:cs typeface="Noto Sans KR" pitchFamily="34" charset="-120"/>
                         </a:rPr>
-                        <a:t>6,114.0</a:t>
+                        <a:t>5,490.0</a:t>
                       </a:r>
                       <a:endParaRPr lang="en-US" sz="1050" dirty="0">
                         <a:latin typeface="Noto Sans KR" charset="0"/>
@@ -21231,7 +21231,7 @@
                           <a:ea typeface="Noto Sans KR" pitchFamily="34" charset="-122"/>
                           <a:cs typeface="Noto Sans KR" pitchFamily="34" charset="-120"/>
                         </a:rPr>
-                        <a:t>920.1</a:t>
+                        <a:t>948.1</a:t>
                       </a:r>
                       <a:endParaRPr lang="en-US" sz="1050" dirty="0">
                         <a:latin typeface="Noto Sans KR" charset="0"/>
@@ -21299,7 +21299,7 @@
                           <a:ea typeface="Noto Sans KR" pitchFamily="34" charset="-122"/>
                           <a:cs typeface="Noto Sans KR" pitchFamily="34" charset="-120"/>
                         </a:rPr>
-                        <a:t>7,446.8</a:t>
+                        <a:t>6,822.8</a:t>
                       </a:r>
                       <a:endParaRPr lang="en-US" sz="1050" dirty="0">
                         <a:latin typeface="Noto Sans KR" charset="0"/>
@@ -21915,7 +21915,7 @@
                           <a:ea typeface="Noto Sans KR" pitchFamily="34" charset="-122"/>
                           <a:cs typeface="Noto Sans KR" pitchFamily="34" charset="-120"/>
                         </a:rPr>
-                        <a:t>755.3</a:t>
+                        <a:t>783.3</a:t>
                       </a:r>
                       <a:endParaRPr lang="en-US" sz="1050" dirty="0">
                         <a:latin typeface="Noto Sans KR" charset="0"/>
@@ -21983,7 +21983,7 @@
                           <a:ea typeface="Noto Sans KR" pitchFamily="34" charset="-122"/>
                           <a:cs typeface="Noto Sans KR" pitchFamily="34" charset="-120"/>
                         </a:rPr>
-                        <a:t>5,469.2</a:t>
+                        <a:t>4,845.2</a:t>
                       </a:r>
                       <a:endParaRPr lang="en-US" sz="1050" dirty="0">
                         <a:latin typeface="Noto Sans KR" charset="0"/>
@@ -22151,7 +22151,7 @@
                 <a:ea typeface="Noto Sans KR" pitchFamily="34" charset="-122"/>
                 <a:cs typeface="Noto Sans KR" pitchFamily="34" charset="-120"/>
               </a:rPr>
-              <a:t>2026 920만 원 · 2027 7,447만 원</a:t>
+              <a:t>2026 948만 원 · 2027 6,823만 원</a:t>
             </a:r>
             <a:endParaRPr lang="en-US" sz="3150" dirty="0"/>
           </a:p>
@@ -22190,7 +22190,7 @@
                 <a:ea typeface="Noto Sans KR" pitchFamily="34" charset="-122"/>
                 <a:cs typeface="Noto Sans KR" pitchFamily="34" charset="-120"/>
               </a:rPr>
-              <a:t>사무실 월 고정비 111.07만 원 + 숙소 188.5만 원 + 파견·차량 운영 · 출장비 절감 차감 시 2027 순증 5,469만 원</a:t>
+              <a:t>사무실 월 고정비 111.07만 원 + 숙소 188.5만 원 + 파견·차량 운영 · 출장비 절감 차감 시 2027 순증 4,845만 원</a:t>
             </a:r>
             <a:endParaRPr lang="en-US" sz="1500" dirty="0"/>
           </a:p>
@@ -22658,7 +22658,7 @@
                 <a:latin typeface="Noto Sans KR"/>
                 <a:ea typeface="Noto Sans KR"/>
               </a:rPr>
-              <a:t>2026은 11~12월 2개월(파견 1인 · 차량 1대), 2027은 12개월(파견 2인 · 차량 2대). 사무실 월 고정비는 두 해 모두 같은 월 금액 적용</a:t>
+              <a:t>2026은 11~12월 2개월(파견 1인 · 차량 1대), 2027은 12개월(파견 2인 · 차량 1대 유지). 사무실 월 고정비는 두 해 모두 같은 월 금액 적용</a:t>
             </a:r>
           </a:p>
           <a:p>
@@ -22751,7 +22751,7 @@
         </p:nvGraphicFramePr>
         <p:xfrm>
           <a:off x="914400" y="2073445"/>
-          <a:ext cx="16459200" cy="2371988"/>
+          <a:ext cx="16459200" cy="2036988"/>
         </p:xfrm>
         <a:graphic>
           <a:graphicData uri="http://schemas.openxmlformats.org/drawingml/2006/table">
@@ -23893,6 +23893,142 @@
                         <a:buNone/>
                       </a:pPr>
                       <a:r>
+                        <a:rPr lang="en-US" sz="1050" dirty="0" b="1">
+                          <a:solidFill>
+                            <a:srgbClr val="0E2240"/>
+                          </a:solidFill>
+                          <a:latin typeface="Noto Sans KR" pitchFamily="34" charset="0"/>
+                          <a:ea typeface="Noto Sans KR" pitchFamily="34" charset="-122"/>
+                          <a:cs typeface="Noto Sans KR" pitchFamily="34" charset="-120"/>
+                        </a:rPr>
+                        <a:t>2026 보증금 소계</a:t>
+                      </a:r>
+                      <a:endParaRPr lang="en-US" sz="1050" dirty="0">
+                        <a:latin typeface="Noto Sans KR" charset="0"/>
+                        <a:ea typeface="Noto Sans KR" charset="0"/>
+                        <a:cs typeface="Noto Sans KR" charset="0"/>
+                      </a:endParaRPr>
+                    </a:p>
+                  </a:txBody>
+                  <a:tcPr marL="152705" marR="152705" marT="30000" marB="30000" anchor="ctr">
+                    <a:lnL w="0" cap="flat" cmpd="sng" algn="ctr">
+                      <a:solidFill>
+                        <a:srgbClr val="C9D9E8"/>
+                      </a:solidFill>
+                      <a:prstDash val="solid"/>
+                      <a:round/>
+                      <a:headEnd type="none" w="med" len="med"/>
+                      <a:tailEnd type="none" w="med" len="med"/>
+                    </a:lnL>
+                    <a:lnR w="0" cap="flat" cmpd="sng" algn="ctr">
+                      <a:solidFill>
+                        <a:srgbClr val="C9D9E8"/>
+                      </a:solidFill>
+                      <a:prstDash val="solid"/>
+                      <a:round/>
+                      <a:headEnd type="none" w="med" len="med"/>
+                      <a:tailEnd type="none" w="med" len="med"/>
+                    </a:lnR>
+                    <a:lnT w="0" cap="flat" cmpd="sng" algn="ctr">
+                      <a:solidFill>
+                        <a:srgbClr val="C9D9E8"/>
+                      </a:solidFill>
+                      <a:prstDash val="solid"/>
+                      <a:round/>
+                      <a:headEnd type="none" w="med" len="med"/>
+                      <a:tailEnd type="none" w="med" len="med"/>
+                    </a:lnT>
+                    <a:lnB w="9525" cap="flat" cmpd="sng" algn="ctr">
+                      <a:solidFill>
+                        <a:srgbClr val="C9D9E8"/>
+                      </a:solidFill>
+                      <a:prstDash val="solid"/>
+                      <a:round/>
+                      <a:headEnd type="none" w="med" len="med"/>
+                      <a:tailEnd type="none" w="med" len="med"/>
+                    </a:lnB>
+                    <a:solidFill>
+                      <a:srgbClr val="DDE9F4"/>
+                    </a:solidFill>
+                  </a:tcPr>
+                </a:tc>
+                <a:tc>
+                  <a:txBody>
+                    <a:bodyPr/>
+                    <a:lstStyle/>
+                    <a:p>
+                      <a:pPr marL="0" indent="0" algn="r">
+                        <a:buNone/>
+                      </a:pPr>
+                      <a:r>
+                        <a:rPr lang="en-US" sz="1050" dirty="0" b="1">
+                          <a:solidFill>
+                            <a:srgbClr val="B8860B"/>
+                          </a:solidFill>
+                          <a:latin typeface="Noto Sans KR" pitchFamily="34" charset="0"/>
+                          <a:ea typeface="Noto Sans KR" pitchFamily="34" charset="-122"/>
+                          <a:cs typeface="Noto Sans KR" pitchFamily="34" charset="-120"/>
+                        </a:rPr>
+                        <a:t>5,352.2</a:t>
+                      </a:r>
+                      <a:endParaRPr lang="en-US" sz="1050" dirty="0">
+                        <a:latin typeface="Noto Sans KR" charset="0"/>
+                        <a:ea typeface="Noto Sans KR" charset="0"/>
+                        <a:cs typeface="Noto Sans KR" charset="0"/>
+                      </a:endParaRPr>
+                    </a:p>
+                  </a:txBody>
+                  <a:tcPr marL="152705" marR="152705" marT="30000" marB="30000" anchor="ctr">
+                    <a:lnL w="0" cap="flat" cmpd="sng" algn="ctr">
+                      <a:solidFill>
+                        <a:srgbClr val="C9D9E8"/>
+                      </a:solidFill>
+                      <a:prstDash val="solid"/>
+                      <a:round/>
+                      <a:headEnd type="none" w="med" len="med"/>
+                      <a:tailEnd type="none" w="med" len="med"/>
+                    </a:lnL>
+                    <a:lnR w="0" cap="flat" cmpd="sng" algn="ctr">
+                      <a:solidFill>
+                        <a:srgbClr val="C9D9E8"/>
+                      </a:solidFill>
+                      <a:prstDash val="solid"/>
+                      <a:round/>
+                      <a:headEnd type="none" w="med" len="med"/>
+                      <a:tailEnd type="none" w="med" len="med"/>
+                    </a:lnR>
+                    <a:lnT w="0" cap="flat" cmpd="sng" algn="ctr">
+                      <a:solidFill>
+                        <a:srgbClr val="C9D9E8"/>
+                      </a:solidFill>
+                      <a:prstDash val="solid"/>
+                      <a:round/>
+                      <a:headEnd type="none" w="med" len="med"/>
+                      <a:tailEnd type="none" w="med" len="med"/>
+                    </a:lnT>
+                    <a:lnB w="9525" cap="flat" cmpd="sng" algn="ctr">
+                      <a:solidFill>
+                        <a:srgbClr val="C9D9E8"/>
+                      </a:solidFill>
+                      <a:prstDash val="solid"/>
+                      <a:round/>
+                      <a:headEnd type="none" w="med" len="med"/>
+                      <a:tailEnd type="none" w="med" len="med"/>
+                    </a:lnB>
+                    <a:solidFill>
+                      <a:srgbClr val="DDE9F4"/>
+                    </a:solidFill>
+                  </a:tcPr>
+                </a:tc>
+                <a:tc>
+                  <a:txBody>
+                    <a:bodyPr/>
+                    <a:lstStyle/>
+                    <a:p>
+                      <a:pPr marL="0" indent="0" algn="l">
+                        <a:buNone/>
+                      </a:pPr>
+                      <a:r>
                         <a:rPr lang="en-US" sz="1050" dirty="0" b="0">
                           <a:solidFill>
                             <a:srgbClr val="1F2A37"/>
@@ -23901,7 +24037,7 @@
                           <a:ea typeface="Noto Sans KR" pitchFamily="34" charset="-122"/>
                           <a:cs typeface="Noto Sans KR" pitchFamily="34" charset="-120"/>
                         </a:rPr>
-                        <a:t>차량 렌트 보증금 (1대)</a:t>
+                        <a:t/>
                       </a:r>
                       <a:endParaRPr lang="en-US" sz="1050" dirty="0">
                         <a:latin typeface="Noto Sans KR" charset="0"/>
@@ -23948,28 +24084,28 @@
                       <a:tailEnd type="none" w="med" len="med"/>
                     </a:lnB>
                     <a:solidFill>
-                      <a:srgbClr val="F7FAFD"/>
-                    </a:solidFill>
-                  </a:tcPr>
-                </a:tc>
-                <a:tc>
-                  <a:txBody>
-                    <a:bodyPr/>
-                    <a:lstStyle/>
-                    <a:p>
-                      <a:pPr marL="0" indent="0" algn="r">
-                        <a:buNone/>
-                      </a:pPr>
-                      <a:r>
-                        <a:rPr lang="en-US" sz="1050" dirty="0" b="1">
-                          <a:solidFill>
-                            <a:srgbClr val="0E2240"/>
-                          </a:solidFill>
-                          <a:latin typeface="Noto Sans KR" pitchFamily="34" charset="0"/>
-                          <a:ea typeface="Noto Sans KR" pitchFamily="34" charset="-122"/>
-                          <a:cs typeface="Noto Sans KR" pitchFamily="34" charset="-120"/>
-                        </a:rPr>
-                        <a:t>≤ 900.0</a:t>
+                      <a:srgbClr val="DDE9F4"/>
+                    </a:solidFill>
+                  </a:tcPr>
+                </a:tc>
+                <a:tc>
+                  <a:txBody>
+                    <a:bodyPr/>
+                    <a:lstStyle/>
+                    <a:p>
+                      <a:pPr marL="0" indent="0" algn="l">
+                        <a:buNone/>
+                      </a:pPr>
+                      <a:r>
+                        <a:rPr lang="en-US" sz="1050" dirty="0" b="0">
+                          <a:solidFill>
+                            <a:srgbClr val="1F2A37"/>
+                          </a:solidFill>
+                          <a:latin typeface="Noto Sans KR" pitchFamily="34" charset="0"/>
+                          <a:ea typeface="Noto Sans KR" pitchFamily="34" charset="-122"/>
+                          <a:cs typeface="Noto Sans KR" pitchFamily="34" charset="-120"/>
+                        </a:rPr>
+                        <a:t/>
                       </a:r>
                       <a:endParaRPr lang="en-US" sz="1050" dirty="0">
                         <a:latin typeface="Noto Sans KR" charset="0"/>
@@ -24016,143 +24152,7 @@
                       <a:tailEnd type="none" w="med" len="med"/>
                     </a:lnB>
                     <a:solidFill>
-                      <a:srgbClr val="F7FAFD"/>
-                    </a:solidFill>
-                  </a:tcPr>
-                </a:tc>
-                <a:tc>
-                  <a:txBody>
-                    <a:bodyPr/>
-                    <a:lstStyle/>
-                    <a:p>
-                      <a:pPr marL="0" indent="0" algn="ctr">
-                        <a:buNone/>
-                      </a:pPr>
-                      <a:r>
-                        <a:rPr lang="en-US" sz="1050" dirty="0" b="0">
-                          <a:solidFill>
-                            <a:srgbClr val="1F2A37"/>
-                          </a:solidFill>
-                          <a:latin typeface="Noto Sans KR" pitchFamily="34" charset="0"/>
-                          <a:ea typeface="Noto Sans KR" pitchFamily="34" charset="-122"/>
-                          <a:cs typeface="Noto Sans KR" pitchFamily="34" charset="-120"/>
-                        </a:rPr>
-                        <a:t>2026.11</a:t>
-                      </a:r>
-                      <a:endParaRPr lang="en-US" sz="1050" dirty="0">
-                        <a:latin typeface="Noto Sans KR" charset="0"/>
-                        <a:ea typeface="Noto Sans KR" charset="0"/>
-                        <a:cs typeface="Noto Sans KR" charset="0"/>
-                      </a:endParaRPr>
-                    </a:p>
-                  </a:txBody>
-                  <a:tcPr marL="152705" marR="152705" marT="30000" marB="30000" anchor="ctr">
-                    <a:lnL w="0" cap="flat" cmpd="sng" algn="ctr">
-                      <a:solidFill>
-                        <a:srgbClr val="C9D9E8"/>
-                      </a:solidFill>
-                      <a:prstDash val="solid"/>
-                      <a:round/>
-                      <a:headEnd type="none" w="med" len="med"/>
-                      <a:tailEnd type="none" w="med" len="med"/>
-                    </a:lnL>
-                    <a:lnR w="0" cap="flat" cmpd="sng" algn="ctr">
-                      <a:solidFill>
-                        <a:srgbClr val="C9D9E8"/>
-                      </a:solidFill>
-                      <a:prstDash val="solid"/>
-                      <a:round/>
-                      <a:headEnd type="none" w="med" len="med"/>
-                      <a:tailEnd type="none" w="med" len="med"/>
-                    </a:lnR>
-                    <a:lnT w="0" cap="flat" cmpd="sng" algn="ctr">
-                      <a:solidFill>
-                        <a:srgbClr val="C9D9E8"/>
-                      </a:solidFill>
-                      <a:prstDash val="solid"/>
-                      <a:round/>
-                      <a:headEnd type="none" w="med" len="med"/>
-                      <a:tailEnd type="none" w="med" len="med"/>
-                    </a:lnT>
-                    <a:lnB w="9525" cap="flat" cmpd="sng" algn="ctr">
-                      <a:solidFill>
-                        <a:srgbClr val="C9D9E8"/>
-                      </a:solidFill>
-                      <a:prstDash val="solid"/>
-                      <a:round/>
-                      <a:headEnd type="none" w="med" len="med"/>
-                      <a:tailEnd type="none" w="med" len="med"/>
-                    </a:lnB>
-                    <a:solidFill>
-                      <a:srgbClr val="F7FAFD"/>
-                    </a:solidFill>
-                  </a:tcPr>
-                </a:tc>
-                <a:tc>
-                  <a:txBody>
-                    <a:bodyPr/>
-                    <a:lstStyle/>
-                    <a:p>
-                      <a:pPr marL="0" indent="0" algn="l">
-                        <a:buNone/>
-                      </a:pPr>
-                      <a:r>
-                        <a:rPr lang="en-US" sz="1050" dirty="0" b="0">
-                          <a:solidFill>
-                            <a:srgbClr val="4D6E8E"/>
-                          </a:solidFill>
-                          <a:latin typeface="Noto Sans KR" pitchFamily="34" charset="0"/>
-                          <a:ea typeface="Noto Sans KR" pitchFamily="34" charset="-122"/>
-                          <a:cs typeface="Noto Sans KR" pitchFamily="34" charset="-120"/>
-                        </a:rPr>
-                        <a:t>차량가의 30% · 700~900 중 상한</a:t>
-                      </a:r>
-                      <a:endParaRPr lang="en-US" sz="1050" dirty="0">
-                        <a:latin typeface="Noto Sans KR" charset="0"/>
-                        <a:ea typeface="Noto Sans KR" charset="0"/>
-                        <a:cs typeface="Noto Sans KR" charset="0"/>
-                      </a:endParaRPr>
-                    </a:p>
-                  </a:txBody>
-                  <a:tcPr marL="152705" marR="152705" marT="30000" marB="30000" anchor="ctr">
-                    <a:lnL w="0" cap="flat" cmpd="sng" algn="ctr">
-                      <a:solidFill>
-                        <a:srgbClr val="C9D9E8"/>
-                      </a:solidFill>
-                      <a:prstDash val="solid"/>
-                      <a:round/>
-                      <a:headEnd type="none" w="med" len="med"/>
-                      <a:tailEnd type="none" w="med" len="med"/>
-                    </a:lnL>
-                    <a:lnR w="0" cap="flat" cmpd="sng" algn="ctr">
-                      <a:solidFill>
-                        <a:srgbClr val="C9D9E8"/>
-                      </a:solidFill>
-                      <a:prstDash val="solid"/>
-                      <a:round/>
-                      <a:headEnd type="none" w="med" len="med"/>
-                      <a:tailEnd type="none" w="med" len="med"/>
-                    </a:lnR>
-                    <a:lnT w="0" cap="flat" cmpd="sng" algn="ctr">
-                      <a:solidFill>
-                        <a:srgbClr val="C9D9E8"/>
-                      </a:solidFill>
-                      <a:prstDash val="solid"/>
-                      <a:round/>
-                      <a:headEnd type="none" w="med" len="med"/>
-                      <a:tailEnd type="none" w="med" len="med"/>
-                    </a:lnT>
-                    <a:lnB w="9525" cap="flat" cmpd="sng" algn="ctr">
-                      <a:solidFill>
-                        <a:srgbClr val="C9D9E8"/>
-                      </a:solidFill>
-                      <a:prstDash val="solid"/>
-                      <a:round/>
-                      <a:headEnd type="none" w="med" len="med"/>
-                      <a:tailEnd type="none" w="med" len="med"/>
-                    </a:lnB>
-                    <a:solidFill>
-                      <a:srgbClr val="F7FAFD"/>
+                      <a:srgbClr val="DDE9F4"/>
                     </a:solidFill>
                   </a:tcPr>
                 </a:tc>
@@ -24167,15 +24167,15 @@
                         <a:buNone/>
                       </a:pPr>
                       <a:r>
-                        <a:rPr lang="en-US" sz="1050" dirty="0" b="1">
-                          <a:solidFill>
-                            <a:srgbClr val="0E2240"/>
-                          </a:solidFill>
-                          <a:latin typeface="Noto Sans KR" pitchFamily="34" charset="0"/>
-                          <a:ea typeface="Noto Sans KR" pitchFamily="34" charset="-122"/>
-                          <a:cs typeface="Noto Sans KR" pitchFamily="34" charset="-120"/>
-                        </a:rPr>
-                        <a:t>2026 보증금 소계</a:t>
+                        <a:rPr lang="en-US" sz="1050" dirty="0" b="0">
+                          <a:solidFill>
+                            <a:srgbClr val="1F2A37"/>
+                          </a:solidFill>
+                          <a:latin typeface="Noto Sans KR" pitchFamily="34" charset="0"/>
+                          <a:ea typeface="Noto Sans KR" pitchFamily="34" charset="-122"/>
+                          <a:cs typeface="Noto Sans KR" pitchFamily="34" charset="-120"/>
+                        </a:rPr>
+                        <a:t>차량 렌트 보증금</a:t>
                       </a:r>
                       <a:endParaRPr lang="en-US" sz="1050" dirty="0">
                         <a:latin typeface="Noto Sans KR" charset="0"/>
@@ -24222,7 +24222,7 @@
                       <a:tailEnd type="none" w="med" len="med"/>
                     </a:lnB>
                     <a:solidFill>
-                      <a:srgbClr val="DDE9F4"/>
+                      <a:srgbClr val="F7FAFD"/>
                     </a:solidFill>
                   </a:tcPr>
                 </a:tc>
@@ -24235,15 +24235,15 @@
                         <a:buNone/>
                       </a:pPr>
                       <a:r>
-                        <a:rPr lang="en-US" sz="1050" dirty="0" b="1">
-                          <a:solidFill>
-                            <a:srgbClr val="B8860B"/>
-                          </a:solidFill>
-                          <a:latin typeface="Noto Sans KR" pitchFamily="34" charset="0"/>
-                          <a:ea typeface="Noto Sans KR" pitchFamily="34" charset="-122"/>
-                          <a:cs typeface="Noto Sans KR" pitchFamily="34" charset="-120"/>
-                        </a:rPr>
-                        <a:t>6,252.2</a:t>
+                        <a:rPr lang="en-US" sz="1050" dirty="0" b="0">
+                          <a:solidFill>
+                            <a:srgbClr val="1F2A37"/>
+                          </a:solidFill>
+                          <a:latin typeface="Noto Sans KR" pitchFamily="34" charset="0"/>
+                          <a:ea typeface="Noto Sans KR" pitchFamily="34" charset="-122"/>
+                          <a:cs typeface="Noto Sans KR" pitchFamily="34" charset="-120"/>
+                        </a:rPr>
+                        <a:t>–</a:t>
                       </a:r>
                       <a:endParaRPr lang="en-US" sz="1050" dirty="0">
                         <a:latin typeface="Noto Sans KR" charset="0"/>
@@ -24290,7 +24290,75 @@
                       <a:tailEnd type="none" w="med" len="med"/>
                     </a:lnB>
                     <a:solidFill>
-                      <a:srgbClr val="DDE9F4"/>
+                      <a:srgbClr val="F7FAFD"/>
+                    </a:solidFill>
+                  </a:tcPr>
+                </a:tc>
+                <a:tc>
+                  <a:txBody>
+                    <a:bodyPr/>
+                    <a:lstStyle/>
+                    <a:p>
+                      <a:pPr marL="0" indent="0" algn="ctr">
+                        <a:buNone/>
+                      </a:pPr>
+                      <a:r>
+                        <a:rPr lang="en-US" sz="1050" dirty="0" b="0">
+                          <a:solidFill>
+                            <a:srgbClr val="1F2A37"/>
+                          </a:solidFill>
+                          <a:latin typeface="Noto Sans KR" pitchFamily="34" charset="0"/>
+                          <a:ea typeface="Noto Sans KR" pitchFamily="34" charset="-122"/>
+                          <a:cs typeface="Noto Sans KR" pitchFamily="34" charset="-120"/>
+                        </a:rPr>
+                        <a:t>–</a:t>
+                      </a:r>
+                      <a:endParaRPr lang="en-US" sz="1050" dirty="0">
+                        <a:latin typeface="Noto Sans KR" charset="0"/>
+                        <a:ea typeface="Noto Sans KR" charset="0"/>
+                        <a:cs typeface="Noto Sans KR" charset="0"/>
+                      </a:endParaRPr>
+                    </a:p>
+                  </a:txBody>
+                  <a:tcPr marL="152705" marR="152705" marT="30000" marB="30000" anchor="ctr">
+                    <a:lnL w="0" cap="flat" cmpd="sng" algn="ctr">
+                      <a:solidFill>
+                        <a:srgbClr val="C9D9E8"/>
+                      </a:solidFill>
+                      <a:prstDash val="solid"/>
+                      <a:round/>
+                      <a:headEnd type="none" w="med" len="med"/>
+                      <a:tailEnd type="none" w="med" len="med"/>
+                    </a:lnL>
+                    <a:lnR w="0" cap="flat" cmpd="sng" algn="ctr">
+                      <a:solidFill>
+                        <a:srgbClr val="C9D9E8"/>
+                      </a:solidFill>
+                      <a:prstDash val="solid"/>
+                      <a:round/>
+                      <a:headEnd type="none" w="med" len="med"/>
+                      <a:tailEnd type="none" w="med" len="med"/>
+                    </a:lnR>
+                    <a:lnT w="0" cap="flat" cmpd="sng" algn="ctr">
+                      <a:solidFill>
+                        <a:srgbClr val="C9D9E8"/>
+                      </a:solidFill>
+                      <a:prstDash val="solid"/>
+                      <a:round/>
+                      <a:headEnd type="none" w="med" len="med"/>
+                      <a:tailEnd type="none" w="med" len="med"/>
+                    </a:lnT>
+                    <a:lnB w="9525" cap="flat" cmpd="sng" algn="ctr">
+                      <a:solidFill>
+                        <a:srgbClr val="C9D9E8"/>
+                      </a:solidFill>
+                      <a:prstDash val="solid"/>
+                      <a:round/>
+                      <a:headEnd type="none" w="med" len="med"/>
+                      <a:tailEnd type="none" w="med" len="med"/>
+                    </a:lnB>
+                    <a:solidFill>
+                      <a:srgbClr val="F7FAFD"/>
                     </a:solidFill>
                   </a:tcPr>
                 </a:tc>
@@ -24305,13 +24373,13 @@
                       <a:r>
                         <a:rPr lang="en-US" sz="1050" dirty="0" b="0">
                           <a:solidFill>
-                            <a:srgbClr val="1F2A37"/>
-                          </a:solidFill>
-                          <a:latin typeface="Noto Sans KR" pitchFamily="34" charset="0"/>
-                          <a:ea typeface="Noto Sans KR" pitchFamily="34" charset="-122"/>
-                          <a:cs typeface="Noto Sans KR" pitchFamily="34" charset="-120"/>
-                        </a:rPr>
-                        <a:t/>
+                            <a:srgbClr val="4D6E8E"/>
+                          </a:solidFill>
+                          <a:latin typeface="Noto Sans KR" pitchFamily="34" charset="0"/>
+                          <a:ea typeface="Noto Sans KR" pitchFamily="34" charset="-122"/>
+                          <a:cs typeface="Noto Sans KR" pitchFamily="34" charset="-120"/>
+                        </a:rPr>
+                        <a:t>1년 렌트 계약 월 50만 원 — 보증금 없음, 2027 추가 차량 없음</a:t>
                       </a:r>
                       <a:endParaRPr lang="en-US" sz="1050" dirty="0">
                         <a:latin typeface="Noto Sans KR" charset="0"/>
@@ -24358,349 +24426,7 @@
                       <a:tailEnd type="none" w="med" len="med"/>
                     </a:lnB>
                     <a:solidFill>
-                      <a:srgbClr val="DDE9F4"/>
-                    </a:solidFill>
-                  </a:tcPr>
-                </a:tc>
-                <a:tc>
-                  <a:txBody>
-                    <a:bodyPr/>
-                    <a:lstStyle/>
-                    <a:p>
-                      <a:pPr marL="0" indent="0" algn="l">
-                        <a:buNone/>
-                      </a:pPr>
-                      <a:r>
-                        <a:rPr lang="en-US" sz="1050" dirty="0" b="0">
-                          <a:solidFill>
-                            <a:srgbClr val="1F2A37"/>
-                          </a:solidFill>
-                          <a:latin typeface="Noto Sans KR" pitchFamily="34" charset="0"/>
-                          <a:ea typeface="Noto Sans KR" pitchFamily="34" charset="-122"/>
-                          <a:cs typeface="Noto Sans KR" pitchFamily="34" charset="-120"/>
-                        </a:rPr>
-                        <a:t/>
-                      </a:r>
-                      <a:endParaRPr lang="en-US" sz="1050" dirty="0">
-                        <a:latin typeface="Noto Sans KR" charset="0"/>
-                        <a:ea typeface="Noto Sans KR" charset="0"/>
-                        <a:cs typeface="Noto Sans KR" charset="0"/>
-                      </a:endParaRPr>
-                    </a:p>
-                  </a:txBody>
-                  <a:tcPr marL="152705" marR="152705" marT="30000" marB="30000" anchor="ctr">
-                    <a:lnL w="0" cap="flat" cmpd="sng" algn="ctr">
-                      <a:solidFill>
-                        <a:srgbClr val="C9D9E8"/>
-                      </a:solidFill>
-                      <a:prstDash val="solid"/>
-                      <a:round/>
-                      <a:headEnd type="none" w="med" len="med"/>
-                      <a:tailEnd type="none" w="med" len="med"/>
-                    </a:lnL>
-                    <a:lnR w="0" cap="flat" cmpd="sng" algn="ctr">
-                      <a:solidFill>
-                        <a:srgbClr val="C9D9E8"/>
-                      </a:solidFill>
-                      <a:prstDash val="solid"/>
-                      <a:round/>
-                      <a:headEnd type="none" w="med" len="med"/>
-                      <a:tailEnd type="none" w="med" len="med"/>
-                    </a:lnR>
-                    <a:lnT w="0" cap="flat" cmpd="sng" algn="ctr">
-                      <a:solidFill>
-                        <a:srgbClr val="C9D9E8"/>
-                      </a:solidFill>
-                      <a:prstDash val="solid"/>
-                      <a:round/>
-                      <a:headEnd type="none" w="med" len="med"/>
-                      <a:tailEnd type="none" w="med" len="med"/>
-                    </a:lnT>
-                    <a:lnB w="9525" cap="flat" cmpd="sng" algn="ctr">
-                      <a:solidFill>
-                        <a:srgbClr val="C9D9E8"/>
-                      </a:solidFill>
-                      <a:prstDash val="solid"/>
-                      <a:round/>
-                      <a:headEnd type="none" w="med" len="med"/>
-                      <a:tailEnd type="none" w="med" len="med"/>
-                    </a:lnB>
-                    <a:solidFill>
-                      <a:srgbClr val="DDE9F4"/>
-                    </a:solidFill>
-                  </a:tcPr>
-                </a:tc>
-              </a:tr>
-              <a:tr h="335000">
-                <a:tc>
-                  <a:txBody>
-                    <a:bodyPr/>
-                    <a:lstStyle/>
-                    <a:p>
-                      <a:pPr marL="0" indent="0" algn="l">
-                        <a:buNone/>
-                      </a:pPr>
-                      <a:r>
-                        <a:rPr lang="en-US" sz="1050" dirty="0" b="0">
-                          <a:solidFill>
-                            <a:srgbClr val="1F2A37"/>
-                          </a:solidFill>
-                          <a:latin typeface="Noto Sans KR" pitchFamily="34" charset="0"/>
-                          <a:ea typeface="Noto Sans KR" pitchFamily="34" charset="-122"/>
-                          <a:cs typeface="Noto Sans KR" pitchFamily="34" charset="-120"/>
-                        </a:rPr>
-                        <a:t>차량 렌트 보증금 (추가 1대)</a:t>
-                      </a:r>
-                      <a:endParaRPr lang="en-US" sz="1050" dirty="0">
-                        <a:latin typeface="Noto Sans KR" charset="0"/>
-                        <a:ea typeface="Noto Sans KR" charset="0"/>
-                        <a:cs typeface="Noto Sans KR" charset="0"/>
-                      </a:endParaRPr>
-                    </a:p>
-                  </a:txBody>
-                  <a:tcPr marL="152705" marR="152705" marT="30000" marB="30000" anchor="ctr">
-                    <a:lnL w="0" cap="flat" cmpd="sng" algn="ctr">
-                      <a:solidFill>
-                        <a:srgbClr val="C9D9E8"/>
-                      </a:solidFill>
-                      <a:prstDash val="solid"/>
-                      <a:round/>
-                      <a:headEnd type="none" w="med" len="med"/>
-                      <a:tailEnd type="none" w="med" len="med"/>
-                    </a:lnL>
-                    <a:lnR w="0" cap="flat" cmpd="sng" algn="ctr">
-                      <a:solidFill>
-                        <a:srgbClr val="C9D9E8"/>
-                      </a:solidFill>
-                      <a:prstDash val="solid"/>
-                      <a:round/>
-                      <a:headEnd type="none" w="med" len="med"/>
-                      <a:tailEnd type="none" w="med" len="med"/>
-                    </a:lnR>
-                    <a:lnT w="0" cap="flat" cmpd="sng" algn="ctr">
-                      <a:solidFill>
-                        <a:srgbClr val="C9D9E8"/>
-                      </a:solidFill>
-                      <a:prstDash val="solid"/>
-                      <a:round/>
-                      <a:headEnd type="none" w="med" len="med"/>
-                      <a:tailEnd type="none" w="med" len="med"/>
-                    </a:lnT>
-                    <a:lnB w="9525" cap="flat" cmpd="sng" algn="ctr">
-                      <a:solidFill>
-                        <a:srgbClr val="C9D9E8"/>
-                      </a:solidFill>
-                      <a:prstDash val="solid"/>
-                      <a:round/>
-                      <a:headEnd type="none" w="med" len="med"/>
-                      <a:tailEnd type="none" w="med" len="med"/>
-                    </a:lnB>
-                    <a:solidFill>
-                      <a:srgbClr val="FFFFFF"/>
-                    </a:solidFill>
-                  </a:tcPr>
-                </a:tc>
-                <a:tc>
-                  <a:txBody>
-                    <a:bodyPr/>
-                    <a:lstStyle/>
-                    <a:p>
-                      <a:pPr marL="0" indent="0" algn="r">
-                        <a:buNone/>
-                      </a:pPr>
-                      <a:r>
-                        <a:rPr lang="en-US" sz="1050" dirty="0" b="0">
-                          <a:solidFill>
-                            <a:srgbClr val="1F2A37"/>
-                          </a:solidFill>
-                          <a:latin typeface="Noto Sans KR" pitchFamily="34" charset="0"/>
-                          <a:ea typeface="Noto Sans KR" pitchFamily="34" charset="-122"/>
-                          <a:cs typeface="Noto Sans KR" pitchFamily="34" charset="-120"/>
-                        </a:rPr>
-                        <a:t>≤ 900.0</a:t>
-                      </a:r>
-                      <a:endParaRPr lang="en-US" sz="1050" dirty="0">
-                        <a:latin typeface="Noto Sans KR" charset="0"/>
-                        <a:ea typeface="Noto Sans KR" charset="0"/>
-                        <a:cs typeface="Noto Sans KR" charset="0"/>
-                      </a:endParaRPr>
-                    </a:p>
-                  </a:txBody>
-                  <a:tcPr marL="152705" marR="152705" marT="30000" marB="30000" anchor="ctr">
-                    <a:lnL w="0" cap="flat" cmpd="sng" algn="ctr">
-                      <a:solidFill>
-                        <a:srgbClr val="C9D9E8"/>
-                      </a:solidFill>
-                      <a:prstDash val="solid"/>
-                      <a:round/>
-                      <a:headEnd type="none" w="med" len="med"/>
-                      <a:tailEnd type="none" w="med" len="med"/>
-                    </a:lnL>
-                    <a:lnR w="0" cap="flat" cmpd="sng" algn="ctr">
-                      <a:solidFill>
-                        <a:srgbClr val="C9D9E8"/>
-                      </a:solidFill>
-                      <a:prstDash val="solid"/>
-                      <a:round/>
-                      <a:headEnd type="none" w="med" len="med"/>
-                      <a:tailEnd type="none" w="med" len="med"/>
-                    </a:lnR>
-                    <a:lnT w="0" cap="flat" cmpd="sng" algn="ctr">
-                      <a:solidFill>
-                        <a:srgbClr val="C9D9E8"/>
-                      </a:solidFill>
-                      <a:prstDash val="solid"/>
-                      <a:round/>
-                      <a:headEnd type="none" w="med" len="med"/>
-                      <a:tailEnd type="none" w="med" len="med"/>
-                    </a:lnT>
-                    <a:lnB w="9525" cap="flat" cmpd="sng" algn="ctr">
-                      <a:solidFill>
-                        <a:srgbClr val="C9D9E8"/>
-                      </a:solidFill>
-                      <a:prstDash val="solid"/>
-                      <a:round/>
-                      <a:headEnd type="none" w="med" len="med"/>
-                      <a:tailEnd type="none" w="med" len="med"/>
-                    </a:lnB>
-                    <a:solidFill>
-                      <a:srgbClr val="FFFFFF"/>
-                    </a:solidFill>
-                  </a:tcPr>
-                </a:tc>
-                <a:tc>
-                  <a:txBody>
-                    <a:bodyPr/>
-                    <a:lstStyle/>
-                    <a:p>
-                      <a:pPr marL="0" indent="0" algn="ctr">
-                        <a:buNone/>
-                      </a:pPr>
-                      <a:r>
-                        <a:rPr lang="en-US" sz="1050" dirty="0" b="0">
-                          <a:solidFill>
-                            <a:srgbClr val="1F2A37"/>
-                          </a:solidFill>
-                          <a:latin typeface="Noto Sans KR" pitchFamily="34" charset="0"/>
-                          <a:ea typeface="Noto Sans KR" pitchFamily="34" charset="-122"/>
-                          <a:cs typeface="Noto Sans KR" pitchFamily="34" charset="-120"/>
-                        </a:rPr>
-                        <a:t>2027.1Q</a:t>
-                      </a:r>
-                      <a:endParaRPr lang="en-US" sz="1050" dirty="0">
-                        <a:latin typeface="Noto Sans KR" charset="0"/>
-                        <a:ea typeface="Noto Sans KR" charset="0"/>
-                        <a:cs typeface="Noto Sans KR" charset="0"/>
-                      </a:endParaRPr>
-                    </a:p>
-                  </a:txBody>
-                  <a:tcPr marL="152705" marR="152705" marT="30000" marB="30000" anchor="ctr">
-                    <a:lnL w="0" cap="flat" cmpd="sng" algn="ctr">
-                      <a:solidFill>
-                        <a:srgbClr val="C9D9E8"/>
-                      </a:solidFill>
-                      <a:prstDash val="solid"/>
-                      <a:round/>
-                      <a:headEnd type="none" w="med" len="med"/>
-                      <a:tailEnd type="none" w="med" len="med"/>
-                    </a:lnL>
-                    <a:lnR w="0" cap="flat" cmpd="sng" algn="ctr">
-                      <a:solidFill>
-                        <a:srgbClr val="C9D9E8"/>
-                      </a:solidFill>
-                      <a:prstDash val="solid"/>
-                      <a:round/>
-                      <a:headEnd type="none" w="med" len="med"/>
-                      <a:tailEnd type="none" w="med" len="med"/>
-                    </a:lnR>
-                    <a:lnT w="0" cap="flat" cmpd="sng" algn="ctr">
-                      <a:solidFill>
-                        <a:srgbClr val="C9D9E8"/>
-                      </a:solidFill>
-                      <a:prstDash val="solid"/>
-                      <a:round/>
-                      <a:headEnd type="none" w="med" len="med"/>
-                      <a:tailEnd type="none" w="med" len="med"/>
-                    </a:lnT>
-                    <a:lnB w="9525" cap="flat" cmpd="sng" algn="ctr">
-                      <a:solidFill>
-                        <a:srgbClr val="C9D9E8"/>
-                      </a:solidFill>
-                      <a:prstDash val="solid"/>
-                      <a:round/>
-                      <a:headEnd type="none" w="med" len="med"/>
-                      <a:tailEnd type="none" w="med" len="med"/>
-                    </a:lnB>
-                    <a:solidFill>
-                      <a:srgbClr val="FFFFFF"/>
-                    </a:solidFill>
-                  </a:tcPr>
-                </a:tc>
-                <a:tc>
-                  <a:txBody>
-                    <a:bodyPr/>
-                    <a:lstStyle/>
-                    <a:p>
-                      <a:pPr marL="0" indent="0" algn="l">
-                        <a:buNone/>
-                      </a:pPr>
-                      <a:r>
-                        <a:rPr lang="en-US" sz="1050" dirty="0" b="0">
-                          <a:solidFill>
-                            <a:srgbClr val="4D6E8E"/>
-                          </a:solidFill>
-                          <a:latin typeface="Noto Sans KR" pitchFamily="34" charset="0"/>
-                          <a:ea typeface="Noto Sans KR" pitchFamily="34" charset="-122"/>
-                          <a:cs typeface="Noto Sans KR" pitchFamily="34" charset="-120"/>
-                        </a:rPr>
-                        <a:t>수석 엔지니어 파견 시</a:t>
-                      </a:r>
-                      <a:endParaRPr lang="en-US" sz="1050" dirty="0">
-                        <a:latin typeface="Noto Sans KR" charset="0"/>
-                        <a:ea typeface="Noto Sans KR" charset="0"/>
-                        <a:cs typeface="Noto Sans KR" charset="0"/>
-                      </a:endParaRPr>
-                    </a:p>
-                  </a:txBody>
-                  <a:tcPr marL="152705" marR="152705" marT="30000" marB="30000" anchor="ctr">
-                    <a:lnL w="0" cap="flat" cmpd="sng" algn="ctr">
-                      <a:solidFill>
-                        <a:srgbClr val="C9D9E8"/>
-                      </a:solidFill>
-                      <a:prstDash val="solid"/>
-                      <a:round/>
-                      <a:headEnd type="none" w="med" len="med"/>
-                      <a:tailEnd type="none" w="med" len="med"/>
-                    </a:lnL>
-                    <a:lnR w="0" cap="flat" cmpd="sng" algn="ctr">
-                      <a:solidFill>
-                        <a:srgbClr val="C9D9E8"/>
-                      </a:solidFill>
-                      <a:prstDash val="solid"/>
-                      <a:round/>
-                      <a:headEnd type="none" w="med" len="med"/>
-                      <a:tailEnd type="none" w="med" len="med"/>
-                    </a:lnR>
-                    <a:lnT w="0" cap="flat" cmpd="sng" algn="ctr">
-                      <a:solidFill>
-                        <a:srgbClr val="C9D9E8"/>
-                      </a:solidFill>
-                      <a:prstDash val="solid"/>
-                      <a:round/>
-                      <a:headEnd type="none" w="med" len="med"/>
-                      <a:tailEnd type="none" w="med" len="med"/>
-                    </a:lnT>
-                    <a:lnB w="9525" cap="flat" cmpd="sng" algn="ctr">
-                      <a:solidFill>
-                        <a:srgbClr val="C9D9E8"/>
-                      </a:solidFill>
-                      <a:prstDash val="solid"/>
-                      <a:round/>
-                      <a:headEnd type="none" w="med" len="med"/>
-                      <a:tailEnd type="none" w="med" len="med"/>
-                    </a:lnB>
-                    <a:solidFill>
-                      <a:srgbClr val="FFFFFF"/>
+                      <a:srgbClr val="F7FAFD"/>
                     </a:solidFill>
                   </a:tcPr>
                 </a:tc>
@@ -24753,7 +24479,7 @@
                 <a:ea typeface="Noto Sans KR" pitchFamily="34" charset="-122"/>
                 <a:cs typeface="Noto Sans KR" pitchFamily="34" charset="-120"/>
               </a:rPr>
-              <a:t>2026 현금 9,115만 원</a:t>
+              <a:t>2026 현금 8,243만 원</a:t>
             </a:r>
             <a:r>
               <a:rPr lang="en-US" sz="3150" b="1" kern="0" spc="-31" dirty="0">
@@ -24764,7 +24490,7 @@
                 <a:ea typeface="Noto Sans KR" pitchFamily="34" charset="-122"/>
                 <a:cs typeface="Noto Sans KR" pitchFamily="34" charset="-120"/>
               </a:rPr>
-              <a:t> (반환 6,252 포함)</a:t>
+              <a:t> (반환 5,352 포함)</a:t>
             </a:r>
             <a:endParaRPr lang="en-US" sz="3150" dirty="0"/>
           </a:p>
@@ -24931,7 +24657,7 @@
         </p:nvSpPr>
         <p:spPr>
           <a:xfrm>
-            <a:off x="914400" y="5188405"/>
+            <a:off x="914400" y="4538405"/>
             <a:ext cx="57607" cy="228600"/>
           </a:xfrm>
           <a:prstGeom prst="roundRect">
@@ -24967,7 +24693,7 @@
         </p:nvSpPr>
         <p:spPr>
           <a:xfrm>
-            <a:off x="1104595" y="5150000"/>
+            <a:off x="1104595" y="4500000"/>
             <a:ext cx="5200000" cy="305410"/>
           </a:xfrm>
           <a:prstGeom prst="rect">
@@ -25006,7 +24732,7 @@
         </p:nvSpPr>
         <p:spPr>
           <a:xfrm>
-            <a:off x="3554595" y="5178347"/>
+            <a:off x="3554595" y="4528347"/>
             <a:ext cx="4000000" cy="247802"/>
           </a:xfrm>
           <a:prstGeom prst="rect">
@@ -25123,7 +24849,7 @@
         </p:nvSpPr>
         <p:spPr>
           <a:xfrm>
-            <a:off x="914400" y="5650000"/>
+            <a:off x="914400" y="4950000"/>
             <a:ext cx="5334000" cy="1100000"/>
           </a:xfrm>
           <a:prstGeom prst="roundRect">
@@ -25171,7 +24897,7 @@
         </p:nvSpPr>
         <p:spPr>
           <a:xfrm>
-            <a:off x="1174400" y="5780000"/>
+            <a:off x="1174400" y="5080000"/>
             <a:ext cx="4934000" cy="420000"/>
           </a:xfrm>
           <a:prstGeom prst="rect">
@@ -25194,7 +24920,7 @@
                 <a:latin typeface="Noto Sans KR"/>
                 <a:ea typeface="Noto Sans KR"/>
               </a:rPr>
-              <a:t>2,862.8</a:t>
+              <a:t>2,890.8</a:t>
             </a:r>
             <a:r>
               <a:rPr sz="1200" b="1">
@@ -25217,7 +24943,7 @@
         </p:nvSpPr>
         <p:spPr>
           <a:xfrm>
-            <a:off x="1174400" y="6250000"/>
+            <a:off x="1174400" y="5550000"/>
             <a:ext cx="4934000" cy="220000"/>
           </a:xfrm>
           <a:prstGeom prst="rect">
@@ -25253,7 +24979,7 @@
         </p:nvSpPr>
         <p:spPr>
           <a:xfrm>
-            <a:off x="1174400" y="6490000"/>
+            <a:off x="1174400" y="5790000"/>
             <a:ext cx="4934000" cy="200000"/>
           </a:xfrm>
           <a:prstGeom prst="rect">
@@ -25276,7 +25002,7 @@
                 <a:latin typeface="Noto Sans KR"/>
                 <a:ea typeface="Noto Sans KR"/>
               </a:rPr>
-              <a:t>일회성 1,942.6 + 운영 920.1</a:t>
+              <a:t>일회성 1,942.6 + 운영 948.1</a:t>
             </a:r>
           </a:p>
         </p:txBody>
@@ -25289,7 +25015,7 @@
         </p:nvSpPr>
         <p:spPr>
           <a:xfrm>
-            <a:off x="6477000" y="5650000"/>
+            <a:off x="6477000" y="4950000"/>
             <a:ext cx="5334000" cy="1100000"/>
           </a:xfrm>
           <a:prstGeom prst="roundRect">
@@ -25337,7 +25063,7 @@
         </p:nvSpPr>
         <p:spPr>
           <a:xfrm>
-            <a:off x="6737000" y="5780000"/>
+            <a:off x="6737000" y="5080000"/>
             <a:ext cx="4934000" cy="420000"/>
           </a:xfrm>
           <a:prstGeom prst="rect">
@@ -25360,7 +25086,7 @@
                 <a:latin typeface="Noto Sans KR"/>
                 <a:ea typeface="Noto Sans KR"/>
               </a:rPr>
-              <a:t>6,252.2</a:t>
+              <a:t>5,352.2</a:t>
             </a:r>
             <a:r>
               <a:rPr sz="1200" b="1">
@@ -25383,7 +25109,7 @@
         </p:nvSpPr>
         <p:spPr>
           <a:xfrm>
-            <a:off x="6737000" y="6250000"/>
+            <a:off x="6737000" y="5550000"/>
             <a:ext cx="4934000" cy="220000"/>
           </a:xfrm>
           <a:prstGeom prst="rect">
@@ -25419,7 +25145,7 @@
         </p:nvSpPr>
         <p:spPr>
           <a:xfrm>
-            <a:off x="6737000" y="6490000"/>
+            <a:off x="6737000" y="5790000"/>
             <a:ext cx="4934000" cy="200000"/>
           </a:xfrm>
           <a:prstGeom prst="rect">
@@ -25455,7 +25181,7 @@
         </p:nvSpPr>
         <p:spPr>
           <a:xfrm>
-            <a:off x="12039600" y="5650000"/>
+            <a:off x="12039600" y="4950000"/>
             <a:ext cx="5334000" cy="1100000"/>
           </a:xfrm>
           <a:prstGeom prst="roundRect">
@@ -25503,7 +25229,7 @@
         </p:nvSpPr>
         <p:spPr>
           <a:xfrm>
-            <a:off x="12299600" y="5780000"/>
+            <a:off x="12299600" y="5080000"/>
             <a:ext cx="4934000" cy="420000"/>
           </a:xfrm>
           <a:prstGeom prst="rect">
@@ -25526,7 +25252,7 @@
                 <a:latin typeface="Noto Sans KR"/>
                 <a:ea typeface="Noto Sans KR"/>
               </a:rPr>
-              <a:t>9,115.0</a:t>
+              <a:t>8,243.0</a:t>
             </a:r>
             <a:r>
               <a:rPr sz="1200" b="1">
@@ -25549,7 +25275,7 @@
         </p:nvSpPr>
         <p:spPr>
           <a:xfrm>
-            <a:off x="12299600" y="6250000"/>
+            <a:off x="12299600" y="5550000"/>
             <a:ext cx="4934000" cy="220000"/>
           </a:xfrm>
           <a:prstGeom prst="rect">
@@ -25585,7 +25311,7 @@
         </p:nvSpPr>
         <p:spPr>
           <a:xfrm>
-            <a:off x="12299600" y="6490000"/>
+            <a:off x="12299600" y="5790000"/>
             <a:ext cx="4934000" cy="200000"/>
           </a:xfrm>
           <a:prstGeom prst="rect">
@@ -25621,7 +25347,7 @@
         </p:nvSpPr>
         <p:spPr>
           <a:xfrm>
-            <a:off x="6288400" y="6030000"/>
+            <a:off x="6288400" y="5330000"/>
             <a:ext cx="150000" cy="300000"/>
           </a:xfrm>
           <a:prstGeom prst="rect">
@@ -25657,7 +25383,7 @@
         </p:nvSpPr>
         <p:spPr>
           <a:xfrm>
-            <a:off x="11851000" y="6030000"/>
+            <a:off x="11851000" y="5330000"/>
             <a:ext cx="150000" cy="300000"/>
           </a:xfrm>
           <a:prstGeom prst="rect">
@@ -25693,7 +25419,7 @@
         </p:nvSpPr>
         <p:spPr>
           <a:xfrm>
-            <a:off x="914400" y="6900000"/>
+            <a:off x="914400" y="6200000"/>
             <a:ext cx="16459200" cy="400000"/>
           </a:xfrm>
           <a:prstGeom prst="rect">
@@ -25716,7 +25442,7 @@
                 <a:latin typeface="Noto Sans KR"/>
                 <a:ea typeface="Noto Sans KR"/>
               </a:rPr>
-              <a:t>※ 차량 렌트 보증금이 대당 금액인지(차량가 30%) 렌트사 견적으로 확인 필요 — 품의는 상한 900만 원 기준. 인건비 0.15억(2026)은 별도.</a:t>
+              <a:t>※ 차량은 1년 렌트 계약(월 50만 원, 보증금 없음)으로 1대 운영 — 2027 추가 렌트 없음. 인건비 0.15억(2026)은 별도.</a:t>
             </a:r>
           </a:p>
         </p:txBody>
@@ -25884,7 +25610,7 @@
                           <a:ea typeface="Noto Sans KR" pitchFamily="34" charset="-122"/>
                           <a:cs typeface="Noto Sans KR" pitchFamily="34" charset="-120"/>
                         </a:rPr>
-                        <a:t>계획서 v10</a:t>
+                        <a:t>계획서 v11</a:t>
                       </a:r>
                       <a:endParaRPr lang="en-US" sz="1125" dirty="0">
                         <a:latin typeface="Noto Sans KR" charset="0"/>
@@ -27594,7 +27320,7 @@
                           <a:ea typeface="Noto Sans KR" pitchFamily="34" charset="-122"/>
                           <a:cs typeface="Noto Sans KR" pitchFamily="34" charset="-120"/>
                         </a:rPr>
-                        <a:t>703.0</a:t>
+                        <a:t>731.0</a:t>
                       </a:r>
                       <a:endParaRPr lang="en-US" sz="1050" dirty="0">
                         <a:latin typeface="Noto Sans KR" charset="0"/>
@@ -27662,7 +27388,7 @@
                           <a:ea typeface="Noto Sans KR" pitchFamily="34" charset="-122"/>
                           <a:cs typeface="Noto Sans KR" pitchFamily="34" charset="-120"/>
                         </a:rPr>
-                        <a:t>755.3</a:t>
+                        <a:t>783.3</a:t>
                       </a:r>
                       <a:endParaRPr lang="en-US" sz="1050" dirty="0">
                         <a:latin typeface="Noto Sans KR" charset="0"/>
@@ -27936,7 +27662,7 @@
                           <a:ea typeface="Noto Sans KR" pitchFamily="34" charset="-122"/>
                           <a:cs typeface="Noto Sans KR" pitchFamily="34" charset="-120"/>
                         </a:rPr>
-                        <a:t>5,392.0</a:t>
+                        <a:t>4,768.0</a:t>
                       </a:r>
                       <a:endParaRPr lang="en-US" sz="1050" dirty="0">
                         <a:latin typeface="Noto Sans KR" charset="0"/>
@@ -28004,7 +27730,7 @@
                           <a:ea typeface="Noto Sans KR" pitchFamily="34" charset="-122"/>
                           <a:cs typeface="Noto Sans KR" pitchFamily="34" charset="-120"/>
                         </a:rPr>
-                        <a:t>5,469.2</a:t>
+                        <a:t>4,845.2</a:t>
                       </a:r>
                       <a:endParaRPr lang="en-US" sz="1050" dirty="0">
                         <a:latin typeface="Noto Sans KR" charset="0"/>
@@ -28229,7 +27955,7 @@
                 <a:ea typeface="Noto Sans KR" pitchFamily="34" charset="-122"/>
                 <a:cs typeface="Noto Sans KR" pitchFamily="34" charset="-120"/>
               </a:rPr>
-              <a:t>계획서(v10) 대비 </a:t>
+              <a:t>계획서(v11) 대비 </a:t>
             </a:r>
             <a:r>
               <a:rPr lang="en-US" sz="3150" b="1" kern="0" spc="-31" dirty="0">
@@ -28952,7 +28678,7 @@
                 <a:latin typeface="Noto Sans KR"/>
                 <a:ea typeface="Noto Sans KR"/>
               </a:rPr>
-              <a:t>차량 보증금 </a:t>
+              <a:t>차량 렌트 </a:t>
             </a:r>
             <a:r>
               <a:rPr sz="1100" b="0">
@@ -28962,7 +28688,7 @@
                 <a:latin typeface="Noto Sans KR"/>
                 <a:ea typeface="Noto Sans KR"/>
               </a:rPr>
-              <a:t>대당 700~900인지 렌트사 견적 확인</a:t>
+              <a:t>1년 계약 월 50만 원 — 보험·정비 포함 조건 확인</a:t>
             </a:r>
           </a:p>
           <a:p>

</xml_diff>

<commit_message>
Switch housing setup cost to standard tier across approval docs and plan v11
Co-Authored-By: Claude Opus 5.5 <noreply@anthropic.com>
Claude-Session: https://claude.ai/code/session_01SrTScNKmsHS34birk48N5j
</commit_message>
<xml_diff>
--- a/output/changwon_budget_request_attachment.pptx
+++ b/output/changwon_budget_request_attachment.pptx
@@ -1574,7 +1574,7 @@
                 <a:ea typeface="Noto Sans KR" pitchFamily="34" charset="-122"/>
                 <a:cs typeface="Noto Sans KR" pitchFamily="34" charset="-120"/>
               </a:rPr>
-              <a:t>2026 개설 집행 2,891만 원 · 2027 운영 예산 6,823만 원 · 보증금 5,352만 원(반환)</a:t>
+              <a:t>2026 개설 집행 3,321만 원 · 2027 운영 예산 6,823만 원 · 보증금 5,352만 원(반환)</a:t>
             </a:r>
             <a:endParaRPr lang="en-US" sz="1950" dirty="0"/>
           </a:p>
@@ -2567,7 +2567,7 @@
                           <a:ea typeface="Noto Sans KR" pitchFamily="34" charset="-122"/>
                           <a:cs typeface="Noto Sans KR" pitchFamily="34" charset="-120"/>
                         </a:rPr>
-                        <a:t>숙소 초기 설치 (실속안)</a:t>
+                        <a:t>숙소 초기 설치 (표준안)</a:t>
                       </a:r>
                       <a:endParaRPr lang="en-US" sz="1050" dirty="0">
                         <a:latin typeface="Noto Sans KR" charset="0"/>
@@ -2635,7 +2635,7 @@
                           <a:ea typeface="Noto Sans KR" pitchFamily="34" charset="-122"/>
                           <a:cs typeface="Noto Sans KR" pitchFamily="34" charset="-120"/>
                         </a:rPr>
-                        <a:t>611</a:t>
+                        <a:t>1,041</a:t>
                       </a:r>
                       <a:endParaRPr lang="en-US" sz="1050" dirty="0">
                         <a:latin typeface="Noto Sans KR" charset="0"/>
@@ -4687,7 +4687,7 @@
                           <a:ea typeface="Noto Sans KR" pitchFamily="34" charset="-122"/>
                           <a:cs typeface="Noto Sans KR" pitchFamily="34" charset="-120"/>
                         </a:rPr>
-                        <a:t>2,891</a:t>
+                        <a:t>3,321</a:t>
                       </a:r>
                       <a:endParaRPr lang="en-US" sz="1050" dirty="0">
                         <a:latin typeface="Noto Sans KR" charset="0"/>
@@ -5949,7 +5949,7 @@
                 <a:ea typeface="Noto Sans KR" pitchFamily="34" charset="-122"/>
                 <a:cs typeface="Noto Sans KR" pitchFamily="34" charset="-120"/>
               </a:rPr>
-              <a:t>2026 집행 2,891만 원</a:t>
+              <a:t>2026 집행 3,321만 원</a:t>
             </a:r>
             <a:r>
               <a:rPr lang="en-US" sz="3150" b="1" kern="0" spc="-31" dirty="0">
@@ -6276,7 +6276,7 @@
                 <a:latin typeface="Noto Sans KR"/>
                 <a:ea typeface="Noto Sans KR"/>
               </a:rPr>
-              <a:t>2,891</a:t>
+              <a:t>3,321</a:t>
             </a:r>
             <a:r>
               <a:rPr sz="1200" b="1">
@@ -6358,7 +6358,7 @@
                 <a:latin typeface="Noto Sans KR"/>
                 <a:ea typeface="Noto Sans KR"/>
               </a:rPr>
-              <a:t>일회성 1,943 + 운영 948</a:t>
+              <a:t>일회성 2,373 + 운영 948</a:t>
             </a:r>
           </a:p>
         </p:txBody>
@@ -7053,7 +7053,7 @@
                 <a:latin typeface="Noto Sans KR"/>
                 <a:ea typeface="Noto Sans KR"/>
               </a:rPr>
-              <a:t>— 2,891만 원 (일회성 1,943 + 11~12월 운영 948)</a:t>
+              <a:t>— 3,321만 원 (일회성 2,373 + 11~12월 운영 948)</a:t>
             </a:r>
           </a:p>
           <a:p>
@@ -12244,7 +12244,7 @@
                 <a:ea typeface="Noto Sans KR" pitchFamily="34" charset="-122"/>
                 <a:cs typeface="Noto Sans KR" pitchFamily="34" charset="-120"/>
               </a:rPr>
-              <a:t>1,943만 원</a:t>
+              <a:t>2,373만 원</a:t>
             </a:r>
             <a:r>
               <a:rPr lang="en-US" sz="3150" b="1" kern="0" spc="-31" dirty="0">
@@ -12255,7 +12255,7 @@
                 <a:ea typeface="Noto Sans KR" pitchFamily="34" charset="-122"/>
                 <a:cs typeface="Noto Sans KR" pitchFamily="34" charset="-120"/>
               </a:rPr>
-              <a:t> — 사무소 1,331 · 숙소 611</a:t>
+              <a:t> — 사무소 1,331 · 숙소 1,041</a:t>
             </a:r>
             <a:endParaRPr lang="en-US" sz="3150" dirty="0"/>
           </a:p>
@@ -12294,7 +12294,7 @@
                 <a:ea typeface="Noto Sans KR" pitchFamily="34" charset="-122"/>
                 <a:cs typeface="Noto Sans KR" pitchFamily="34" charset="-120"/>
               </a:rPr>
-              <a:t>사무소: 68개 품목 체크리스트 중 표준안(필수 + 권장) 55개 + 예비비 10% · 숙소: A4 주거비 상세의 실속안 기준</a:t>
+              <a:t>사무소: 68개 품목 체크리스트 중 표준안(필수 + 권장) 55개 + 예비비 10% · 숙소: A4 주거비 상세의 표준안 기준</a:t>
             </a:r>
             <a:endParaRPr lang="en-US" sz="1500" dirty="0"/>
           </a:p>
@@ -13078,77 +13078,77 @@
                         <a:buNone/>
                       </a:pPr>
                       <a:r>
+                        <a:rPr lang="en-US" altLang="ko-KR" sz="1050" b="0" dirty="0" err="1">
+                          <a:solidFill>
+                            <a:srgbClr val="1F2A37"/>
+                          </a:solidFill>
+                          <a:latin typeface="Noto Sans KR" pitchFamily="34" charset="0"/>
+                          <a:ea typeface="Noto Sans KR" pitchFamily="34" charset="-122"/>
+                          <a:cs typeface="Noto Sans KR" pitchFamily="34" charset="-120"/>
+                        </a:rPr>
+                        <a:t>95.0</a:t>
+                      </a:r>
+                      <a:endParaRPr lang="en-US" sz="1050" dirty="0">
+                        <a:latin typeface="Noto Sans KR" charset="0"/>
+                        <a:ea typeface="Noto Sans KR" charset="0"/>
+                        <a:cs typeface="Noto Sans KR" charset="0"/>
+                      </a:endParaRPr>
+                    </a:p>
+                  </a:txBody>
+                  <a:tcPr marL="152705" marR="152705" marT="30000" marB="30000" anchor="ctr">
+                    <a:lnL w="0" cap="flat" cmpd="sng" algn="ctr">
+                      <a:solidFill>
+                        <a:srgbClr val="C9D9E8"/>
+                      </a:solidFill>
+                      <a:prstDash val="solid"/>
+                      <a:round/>
+                      <a:headEnd type="none" w="med" len="med"/>
+                      <a:tailEnd type="none" w="med" len="med"/>
+                    </a:lnL>
+                    <a:lnR w="0" cap="flat" cmpd="sng" algn="ctr">
+                      <a:solidFill>
+                        <a:srgbClr val="C9D9E8"/>
+                      </a:solidFill>
+                      <a:prstDash val="solid"/>
+                      <a:round/>
+                      <a:headEnd type="none" w="med" len="med"/>
+                      <a:tailEnd type="none" w="med" len="med"/>
+                    </a:lnR>
+                    <a:lnT w="0" cap="flat" cmpd="sng" algn="ctr">
+                      <a:solidFill>
+                        <a:srgbClr val="C9D9E8"/>
+                      </a:solidFill>
+                      <a:prstDash val="solid"/>
+                      <a:round/>
+                      <a:headEnd type="none" w="med" len="med"/>
+                      <a:tailEnd type="none" w="med" len="med"/>
+                    </a:lnT>
+                    <a:lnB w="9525" cap="flat" cmpd="sng" algn="ctr">
+                      <a:solidFill>
+                        <a:srgbClr val="C9D9E8"/>
+                      </a:solidFill>
+                      <a:prstDash val="solid"/>
+                      <a:round/>
+                      <a:headEnd type="none" w="med" len="med"/>
+                      <a:tailEnd type="none" w="med" len="med"/>
+                    </a:lnB>
+                    <a:solidFill>
+                      <a:srgbClr val="FFFFFF"/>
+                    </a:solidFill>
+                  </a:tcPr>
+                </a:tc>
+                <a:tc>
+                  <a:txBody>
+                    <a:bodyPr/>
+                    <a:lstStyle/>
+                    <a:p>
+                      <a:pPr marL="0" indent="0" algn="r">
+                        <a:buNone/>
+                      </a:pPr>
+                      <a:r>
                         <a:rPr lang="en-US" altLang="ko-KR" sz="1050" b="1" dirty="0" err="1">
                           <a:solidFill>
                             <a:srgbClr val="0E2240"/>
-                          </a:solidFill>
-                          <a:latin typeface="Noto Sans KR" pitchFamily="34" charset="0"/>
-                          <a:ea typeface="Noto Sans KR" pitchFamily="34" charset="-122"/>
-                          <a:cs typeface="Noto Sans KR" pitchFamily="34" charset="-120"/>
-                        </a:rPr>
-                        <a:t>95.0</a:t>
-                      </a:r>
-                      <a:endParaRPr lang="en-US" sz="1050" dirty="0">
-                        <a:latin typeface="Noto Sans KR" charset="0"/>
-                        <a:ea typeface="Noto Sans KR" charset="0"/>
-                        <a:cs typeface="Noto Sans KR" charset="0"/>
-                      </a:endParaRPr>
-                    </a:p>
-                  </a:txBody>
-                  <a:tcPr marL="152705" marR="152705" marT="30000" marB="30000" anchor="ctr">
-                    <a:lnL w="0" cap="flat" cmpd="sng" algn="ctr">
-                      <a:solidFill>
-                        <a:srgbClr val="C9D9E8"/>
-                      </a:solidFill>
-                      <a:prstDash val="solid"/>
-                      <a:round/>
-                      <a:headEnd type="none" w="med" len="med"/>
-                      <a:tailEnd type="none" w="med" len="med"/>
-                    </a:lnL>
-                    <a:lnR w="0" cap="flat" cmpd="sng" algn="ctr">
-                      <a:solidFill>
-                        <a:srgbClr val="C9D9E8"/>
-                      </a:solidFill>
-                      <a:prstDash val="solid"/>
-                      <a:round/>
-                      <a:headEnd type="none" w="med" len="med"/>
-                      <a:tailEnd type="none" w="med" len="med"/>
-                    </a:lnR>
-                    <a:lnT w="0" cap="flat" cmpd="sng" algn="ctr">
-                      <a:solidFill>
-                        <a:srgbClr val="C9D9E8"/>
-                      </a:solidFill>
-                      <a:prstDash val="solid"/>
-                      <a:round/>
-                      <a:headEnd type="none" w="med" len="med"/>
-                      <a:tailEnd type="none" w="med" len="med"/>
-                    </a:lnT>
-                    <a:lnB w="9525" cap="flat" cmpd="sng" algn="ctr">
-                      <a:solidFill>
-                        <a:srgbClr val="C9D9E8"/>
-                      </a:solidFill>
-                      <a:prstDash val="solid"/>
-                      <a:round/>
-                      <a:headEnd type="none" w="med" len="med"/>
-                      <a:tailEnd type="none" w="med" len="med"/>
-                    </a:lnB>
-                    <a:solidFill>
-                      <a:srgbClr val="FFFFFF"/>
-                    </a:solidFill>
-                  </a:tcPr>
-                </a:tc>
-                <a:tc>
-                  <a:txBody>
-                    <a:bodyPr/>
-                    <a:lstStyle/>
-                    <a:p>
-                      <a:pPr marL="0" indent="0" algn="r">
-                        <a:buNone/>
-                      </a:pPr>
-                      <a:r>
-                        <a:rPr lang="en-US" altLang="ko-KR" sz="1050" b="0" dirty="0" err="1">
-                          <a:solidFill>
-                            <a:srgbClr val="1F2A37"/>
                           </a:solidFill>
                           <a:latin typeface="Noto Sans KR" pitchFamily="34" charset="0"/>
                           <a:ea typeface="Noto Sans KR" pitchFamily="34" charset="-122"/>
@@ -13352,77 +13352,77 @@
                         <a:buNone/>
                       </a:pPr>
                       <a:r>
+                        <a:rPr lang="en-US" altLang="ko-KR" sz="1050" b="0" dirty="0" err="1">
+                          <a:solidFill>
+                            <a:srgbClr val="1F2A37"/>
+                          </a:solidFill>
+                          <a:latin typeface="Noto Sans KR" pitchFamily="34" charset="0"/>
+                          <a:ea typeface="Noto Sans KR" pitchFamily="34" charset="-122"/>
+                          <a:cs typeface="Noto Sans KR" pitchFamily="34" charset="-120"/>
+                        </a:rPr>
+                        <a:t>126.0</a:t>
+                      </a:r>
+                      <a:endParaRPr lang="en-US" sz="1050" dirty="0">
+                        <a:latin typeface="Noto Sans KR" charset="0"/>
+                        <a:ea typeface="Noto Sans KR" charset="0"/>
+                        <a:cs typeface="Noto Sans KR" charset="0"/>
+                      </a:endParaRPr>
+                    </a:p>
+                  </a:txBody>
+                  <a:tcPr marL="152705" marR="152705" marT="30000" marB="30000" anchor="ctr">
+                    <a:lnL w="0" cap="flat" cmpd="sng" algn="ctr">
+                      <a:solidFill>
+                        <a:srgbClr val="C9D9E8"/>
+                      </a:solidFill>
+                      <a:prstDash val="solid"/>
+                      <a:round/>
+                      <a:headEnd type="none" w="med" len="med"/>
+                      <a:tailEnd type="none" w="med" len="med"/>
+                    </a:lnL>
+                    <a:lnR w="0" cap="flat" cmpd="sng" algn="ctr">
+                      <a:solidFill>
+                        <a:srgbClr val="C9D9E8"/>
+                      </a:solidFill>
+                      <a:prstDash val="solid"/>
+                      <a:round/>
+                      <a:headEnd type="none" w="med" len="med"/>
+                      <a:tailEnd type="none" w="med" len="med"/>
+                    </a:lnR>
+                    <a:lnT w="0" cap="flat" cmpd="sng" algn="ctr">
+                      <a:solidFill>
+                        <a:srgbClr val="C9D9E8"/>
+                      </a:solidFill>
+                      <a:prstDash val="solid"/>
+                      <a:round/>
+                      <a:headEnd type="none" w="med" len="med"/>
+                      <a:tailEnd type="none" w="med" len="med"/>
+                    </a:lnT>
+                    <a:lnB w="9525" cap="flat" cmpd="sng" algn="ctr">
+                      <a:solidFill>
+                        <a:srgbClr val="C9D9E8"/>
+                      </a:solidFill>
+                      <a:prstDash val="solid"/>
+                      <a:round/>
+                      <a:headEnd type="none" w="med" len="med"/>
+                      <a:tailEnd type="none" w="med" len="med"/>
+                    </a:lnB>
+                    <a:solidFill>
+                      <a:srgbClr val="F7FAFD"/>
+                    </a:solidFill>
+                  </a:tcPr>
+                </a:tc>
+                <a:tc>
+                  <a:txBody>
+                    <a:bodyPr/>
+                    <a:lstStyle/>
+                    <a:p>
+                      <a:pPr marL="0" indent="0" algn="r">
+                        <a:buNone/>
+                      </a:pPr>
+                      <a:r>
                         <a:rPr lang="en-US" altLang="ko-KR" sz="1050" b="1" dirty="0" err="1">
                           <a:solidFill>
                             <a:srgbClr val="0E2240"/>
-                          </a:solidFill>
-                          <a:latin typeface="Noto Sans KR" pitchFamily="34" charset="0"/>
-                          <a:ea typeface="Noto Sans KR" pitchFamily="34" charset="-122"/>
-                          <a:cs typeface="Noto Sans KR" pitchFamily="34" charset="-120"/>
-                        </a:rPr>
-                        <a:t>126.0</a:t>
-                      </a:r>
-                      <a:endParaRPr lang="en-US" sz="1050" dirty="0">
-                        <a:latin typeface="Noto Sans KR" charset="0"/>
-                        <a:ea typeface="Noto Sans KR" charset="0"/>
-                        <a:cs typeface="Noto Sans KR" charset="0"/>
-                      </a:endParaRPr>
-                    </a:p>
-                  </a:txBody>
-                  <a:tcPr marL="152705" marR="152705" marT="30000" marB="30000" anchor="ctr">
-                    <a:lnL w="0" cap="flat" cmpd="sng" algn="ctr">
-                      <a:solidFill>
-                        <a:srgbClr val="C9D9E8"/>
-                      </a:solidFill>
-                      <a:prstDash val="solid"/>
-                      <a:round/>
-                      <a:headEnd type="none" w="med" len="med"/>
-                      <a:tailEnd type="none" w="med" len="med"/>
-                    </a:lnL>
-                    <a:lnR w="0" cap="flat" cmpd="sng" algn="ctr">
-                      <a:solidFill>
-                        <a:srgbClr val="C9D9E8"/>
-                      </a:solidFill>
-                      <a:prstDash val="solid"/>
-                      <a:round/>
-                      <a:headEnd type="none" w="med" len="med"/>
-                      <a:tailEnd type="none" w="med" len="med"/>
-                    </a:lnR>
-                    <a:lnT w="0" cap="flat" cmpd="sng" algn="ctr">
-                      <a:solidFill>
-                        <a:srgbClr val="C9D9E8"/>
-                      </a:solidFill>
-                      <a:prstDash val="solid"/>
-                      <a:round/>
-                      <a:headEnd type="none" w="med" len="med"/>
-                      <a:tailEnd type="none" w="med" len="med"/>
-                    </a:lnT>
-                    <a:lnB w="9525" cap="flat" cmpd="sng" algn="ctr">
-                      <a:solidFill>
-                        <a:srgbClr val="C9D9E8"/>
-                      </a:solidFill>
-                      <a:prstDash val="solid"/>
-                      <a:round/>
-                      <a:headEnd type="none" w="med" len="med"/>
-                      <a:tailEnd type="none" w="med" len="med"/>
-                    </a:lnB>
-                    <a:solidFill>
-                      <a:srgbClr val="F7FAFD"/>
-                    </a:solidFill>
-                  </a:tcPr>
-                </a:tc>
-                <a:tc>
-                  <a:txBody>
-                    <a:bodyPr/>
-                    <a:lstStyle/>
-                    <a:p>
-                      <a:pPr marL="0" indent="0" algn="r">
-                        <a:buNone/>
-                      </a:pPr>
-                      <a:r>
-                        <a:rPr lang="en-US" altLang="ko-KR" sz="1050" b="0" dirty="0" err="1">
-                          <a:solidFill>
-                            <a:srgbClr val="1F2A37"/>
                           </a:solidFill>
                           <a:latin typeface="Noto Sans KR" pitchFamily="34" charset="0"/>
                           <a:ea typeface="Noto Sans KR" pitchFamily="34" charset="-122"/>
@@ -13626,77 +13626,77 @@
                         <a:buNone/>
                       </a:pPr>
                       <a:r>
+                        <a:rPr lang="en-US" altLang="ko-KR" sz="1050" b="0" dirty="0" err="1">
+                          <a:solidFill>
+                            <a:srgbClr val="1F2A37"/>
+                          </a:solidFill>
+                          <a:latin typeface="Noto Sans KR" pitchFamily="34" charset="0"/>
+                          <a:ea typeface="Noto Sans KR" pitchFamily="34" charset="-122"/>
+                          <a:cs typeface="Noto Sans KR" pitchFamily="34" charset="-120"/>
+                        </a:rPr>
+                        <a:t>50.0</a:t>
+                      </a:r>
+                      <a:endParaRPr lang="en-US" sz="1050" dirty="0">
+                        <a:latin typeface="Noto Sans KR" charset="0"/>
+                        <a:ea typeface="Noto Sans KR" charset="0"/>
+                        <a:cs typeface="Noto Sans KR" charset="0"/>
+                      </a:endParaRPr>
+                    </a:p>
+                  </a:txBody>
+                  <a:tcPr marL="152705" marR="152705" marT="30000" marB="30000" anchor="ctr">
+                    <a:lnL w="0" cap="flat" cmpd="sng" algn="ctr">
+                      <a:solidFill>
+                        <a:srgbClr val="C9D9E8"/>
+                      </a:solidFill>
+                      <a:prstDash val="solid"/>
+                      <a:round/>
+                      <a:headEnd type="none" w="med" len="med"/>
+                      <a:tailEnd type="none" w="med" len="med"/>
+                    </a:lnL>
+                    <a:lnR w="0" cap="flat" cmpd="sng" algn="ctr">
+                      <a:solidFill>
+                        <a:srgbClr val="C9D9E8"/>
+                      </a:solidFill>
+                      <a:prstDash val="solid"/>
+                      <a:round/>
+                      <a:headEnd type="none" w="med" len="med"/>
+                      <a:tailEnd type="none" w="med" len="med"/>
+                    </a:lnR>
+                    <a:lnT w="0" cap="flat" cmpd="sng" algn="ctr">
+                      <a:solidFill>
+                        <a:srgbClr val="C9D9E8"/>
+                      </a:solidFill>
+                      <a:prstDash val="solid"/>
+                      <a:round/>
+                      <a:headEnd type="none" w="med" len="med"/>
+                      <a:tailEnd type="none" w="med" len="med"/>
+                    </a:lnT>
+                    <a:lnB w="9525" cap="flat" cmpd="sng" algn="ctr">
+                      <a:solidFill>
+                        <a:srgbClr val="C9D9E8"/>
+                      </a:solidFill>
+                      <a:prstDash val="solid"/>
+                      <a:round/>
+                      <a:headEnd type="none" w="med" len="med"/>
+                      <a:tailEnd type="none" w="med" len="med"/>
+                    </a:lnB>
+                    <a:solidFill>
+                      <a:srgbClr val="FFFFFF"/>
+                    </a:solidFill>
+                  </a:tcPr>
+                </a:tc>
+                <a:tc>
+                  <a:txBody>
+                    <a:bodyPr/>
+                    <a:lstStyle/>
+                    <a:p>
+                      <a:pPr marL="0" indent="0" algn="r">
+                        <a:buNone/>
+                      </a:pPr>
+                      <a:r>
                         <a:rPr lang="en-US" altLang="ko-KR" sz="1050" b="1" dirty="0" err="1">
                           <a:solidFill>
                             <a:srgbClr val="0E2240"/>
-                          </a:solidFill>
-                          <a:latin typeface="Noto Sans KR" pitchFamily="34" charset="0"/>
-                          <a:ea typeface="Noto Sans KR" pitchFamily="34" charset="-122"/>
-                          <a:cs typeface="Noto Sans KR" pitchFamily="34" charset="-120"/>
-                        </a:rPr>
-                        <a:t>50.0</a:t>
-                      </a:r>
-                      <a:endParaRPr lang="en-US" sz="1050" dirty="0">
-                        <a:latin typeface="Noto Sans KR" charset="0"/>
-                        <a:ea typeface="Noto Sans KR" charset="0"/>
-                        <a:cs typeface="Noto Sans KR" charset="0"/>
-                      </a:endParaRPr>
-                    </a:p>
-                  </a:txBody>
-                  <a:tcPr marL="152705" marR="152705" marT="30000" marB="30000" anchor="ctr">
-                    <a:lnL w="0" cap="flat" cmpd="sng" algn="ctr">
-                      <a:solidFill>
-                        <a:srgbClr val="C9D9E8"/>
-                      </a:solidFill>
-                      <a:prstDash val="solid"/>
-                      <a:round/>
-                      <a:headEnd type="none" w="med" len="med"/>
-                      <a:tailEnd type="none" w="med" len="med"/>
-                    </a:lnL>
-                    <a:lnR w="0" cap="flat" cmpd="sng" algn="ctr">
-                      <a:solidFill>
-                        <a:srgbClr val="C9D9E8"/>
-                      </a:solidFill>
-                      <a:prstDash val="solid"/>
-                      <a:round/>
-                      <a:headEnd type="none" w="med" len="med"/>
-                      <a:tailEnd type="none" w="med" len="med"/>
-                    </a:lnR>
-                    <a:lnT w="0" cap="flat" cmpd="sng" algn="ctr">
-                      <a:solidFill>
-                        <a:srgbClr val="C9D9E8"/>
-                      </a:solidFill>
-                      <a:prstDash val="solid"/>
-                      <a:round/>
-                      <a:headEnd type="none" w="med" len="med"/>
-                      <a:tailEnd type="none" w="med" len="med"/>
-                    </a:lnT>
-                    <a:lnB w="9525" cap="flat" cmpd="sng" algn="ctr">
-                      <a:solidFill>
-                        <a:srgbClr val="C9D9E8"/>
-                      </a:solidFill>
-                      <a:prstDash val="solid"/>
-                      <a:round/>
-                      <a:headEnd type="none" w="med" len="med"/>
-                      <a:tailEnd type="none" w="med" len="med"/>
-                    </a:lnB>
-                    <a:solidFill>
-                      <a:srgbClr val="FFFFFF"/>
-                    </a:solidFill>
-                  </a:tcPr>
-                </a:tc>
-                <a:tc>
-                  <a:txBody>
-                    <a:bodyPr/>
-                    <a:lstStyle/>
-                    <a:p>
-                      <a:pPr marL="0" indent="0" algn="r">
-                        <a:buNone/>
-                      </a:pPr>
-                      <a:r>
-                        <a:rPr lang="en-US" altLang="ko-KR" sz="1050" b="0" dirty="0" err="1">
-                          <a:solidFill>
-                            <a:srgbClr val="1F2A37"/>
                           </a:solidFill>
                           <a:latin typeface="Noto Sans KR" pitchFamily="34" charset="0"/>
                           <a:ea typeface="Noto Sans KR" pitchFamily="34" charset="-122"/>
@@ -13900,77 +13900,77 @@
                         <a:buNone/>
                       </a:pPr>
                       <a:r>
+                        <a:rPr lang="en-US" altLang="ko-KR" sz="1050" b="0" dirty="0" err="1">
+                          <a:solidFill>
+                            <a:srgbClr val="1F2A37"/>
+                          </a:solidFill>
+                          <a:latin typeface="Noto Sans KR" pitchFamily="34" charset="0"/>
+                          <a:ea typeface="Noto Sans KR" pitchFamily="34" charset="-122"/>
+                          <a:cs typeface="Noto Sans KR" pitchFamily="34" charset="-120"/>
+                        </a:rPr>
+                        <a:t>244.4</a:t>
+                      </a:r>
+                      <a:endParaRPr lang="en-US" sz="1050" dirty="0">
+                        <a:latin typeface="Noto Sans KR" charset="0"/>
+                        <a:ea typeface="Noto Sans KR" charset="0"/>
+                        <a:cs typeface="Noto Sans KR" charset="0"/>
+                      </a:endParaRPr>
+                    </a:p>
+                  </a:txBody>
+                  <a:tcPr marL="152705" marR="152705" marT="30000" marB="30000" anchor="ctr">
+                    <a:lnL w="0" cap="flat" cmpd="sng" algn="ctr">
+                      <a:solidFill>
+                        <a:srgbClr val="C9D9E8"/>
+                      </a:solidFill>
+                      <a:prstDash val="solid"/>
+                      <a:round/>
+                      <a:headEnd type="none" w="med" len="med"/>
+                      <a:tailEnd type="none" w="med" len="med"/>
+                    </a:lnL>
+                    <a:lnR w="0" cap="flat" cmpd="sng" algn="ctr">
+                      <a:solidFill>
+                        <a:srgbClr val="C9D9E8"/>
+                      </a:solidFill>
+                      <a:prstDash val="solid"/>
+                      <a:round/>
+                      <a:headEnd type="none" w="med" len="med"/>
+                      <a:tailEnd type="none" w="med" len="med"/>
+                    </a:lnR>
+                    <a:lnT w="0" cap="flat" cmpd="sng" algn="ctr">
+                      <a:solidFill>
+                        <a:srgbClr val="C9D9E8"/>
+                      </a:solidFill>
+                      <a:prstDash val="solid"/>
+                      <a:round/>
+                      <a:headEnd type="none" w="med" len="med"/>
+                      <a:tailEnd type="none" w="med" len="med"/>
+                    </a:lnT>
+                    <a:lnB w="9525" cap="flat" cmpd="sng" algn="ctr">
+                      <a:solidFill>
+                        <a:srgbClr val="C9D9E8"/>
+                      </a:solidFill>
+                      <a:prstDash val="solid"/>
+                      <a:round/>
+                      <a:headEnd type="none" w="med" len="med"/>
+                      <a:tailEnd type="none" w="med" len="med"/>
+                    </a:lnB>
+                    <a:solidFill>
+                      <a:srgbClr val="F7FAFD"/>
+                    </a:solidFill>
+                  </a:tcPr>
+                </a:tc>
+                <a:tc>
+                  <a:txBody>
+                    <a:bodyPr/>
+                    <a:lstStyle/>
+                    <a:p>
+                      <a:pPr marL="0" indent="0" algn="r">
+                        <a:buNone/>
+                      </a:pPr>
+                      <a:r>
                         <a:rPr lang="en-US" altLang="ko-KR" sz="1050" b="1" dirty="0" err="1">
                           <a:solidFill>
                             <a:srgbClr val="0E2240"/>
-                          </a:solidFill>
-                          <a:latin typeface="Noto Sans KR" pitchFamily="34" charset="0"/>
-                          <a:ea typeface="Noto Sans KR" pitchFamily="34" charset="-122"/>
-                          <a:cs typeface="Noto Sans KR" pitchFamily="34" charset="-120"/>
-                        </a:rPr>
-                        <a:t>244.4</a:t>
-                      </a:r>
-                      <a:endParaRPr lang="en-US" sz="1050" dirty="0">
-                        <a:latin typeface="Noto Sans KR" charset="0"/>
-                        <a:ea typeface="Noto Sans KR" charset="0"/>
-                        <a:cs typeface="Noto Sans KR" charset="0"/>
-                      </a:endParaRPr>
-                    </a:p>
-                  </a:txBody>
-                  <a:tcPr marL="152705" marR="152705" marT="30000" marB="30000" anchor="ctr">
-                    <a:lnL w="0" cap="flat" cmpd="sng" algn="ctr">
-                      <a:solidFill>
-                        <a:srgbClr val="C9D9E8"/>
-                      </a:solidFill>
-                      <a:prstDash val="solid"/>
-                      <a:round/>
-                      <a:headEnd type="none" w="med" len="med"/>
-                      <a:tailEnd type="none" w="med" len="med"/>
-                    </a:lnL>
-                    <a:lnR w="0" cap="flat" cmpd="sng" algn="ctr">
-                      <a:solidFill>
-                        <a:srgbClr val="C9D9E8"/>
-                      </a:solidFill>
-                      <a:prstDash val="solid"/>
-                      <a:round/>
-                      <a:headEnd type="none" w="med" len="med"/>
-                      <a:tailEnd type="none" w="med" len="med"/>
-                    </a:lnR>
-                    <a:lnT w="0" cap="flat" cmpd="sng" algn="ctr">
-                      <a:solidFill>
-                        <a:srgbClr val="C9D9E8"/>
-                      </a:solidFill>
-                      <a:prstDash val="solid"/>
-                      <a:round/>
-                      <a:headEnd type="none" w="med" len="med"/>
-                      <a:tailEnd type="none" w="med" len="med"/>
-                    </a:lnT>
-                    <a:lnB w="9525" cap="flat" cmpd="sng" algn="ctr">
-                      <a:solidFill>
-                        <a:srgbClr val="C9D9E8"/>
-                      </a:solidFill>
-                      <a:prstDash val="solid"/>
-                      <a:round/>
-                      <a:headEnd type="none" w="med" len="med"/>
-                      <a:tailEnd type="none" w="med" len="med"/>
-                    </a:lnB>
-                    <a:solidFill>
-                      <a:srgbClr val="F7FAFD"/>
-                    </a:solidFill>
-                  </a:tcPr>
-                </a:tc>
-                <a:tc>
-                  <a:txBody>
-                    <a:bodyPr/>
-                    <a:lstStyle/>
-                    <a:p>
-                      <a:pPr marL="0" indent="0" algn="r">
-                        <a:buNone/>
-                      </a:pPr>
-                      <a:r>
-                        <a:rPr lang="en-US" altLang="ko-KR" sz="1050" b="0" dirty="0" err="1">
-                          <a:solidFill>
-                            <a:srgbClr val="1F2A37"/>
                           </a:solidFill>
                           <a:latin typeface="Noto Sans KR" pitchFamily="34" charset="0"/>
                           <a:ea typeface="Noto Sans KR" pitchFamily="34" charset="-122"/>
@@ -14174,77 +14174,77 @@
                         <a:buNone/>
                       </a:pPr>
                       <a:r>
+                        <a:rPr lang="en-US" altLang="ko-KR" sz="1050" b="0" dirty="0" err="1">
+                          <a:solidFill>
+                            <a:srgbClr val="1F2A37"/>
+                          </a:solidFill>
+                          <a:latin typeface="Noto Sans KR" pitchFamily="34" charset="0"/>
+                          <a:ea typeface="Noto Sans KR" pitchFamily="34" charset="-122"/>
+                          <a:cs typeface="Noto Sans KR" pitchFamily="34" charset="-120"/>
+                        </a:rPr>
+                        <a:t>66.0</a:t>
+                      </a:r>
+                      <a:endParaRPr lang="en-US" sz="1050" dirty="0">
+                        <a:latin typeface="Noto Sans KR" charset="0"/>
+                        <a:ea typeface="Noto Sans KR" charset="0"/>
+                        <a:cs typeface="Noto Sans KR" charset="0"/>
+                      </a:endParaRPr>
+                    </a:p>
+                  </a:txBody>
+                  <a:tcPr marL="152705" marR="152705" marT="30000" marB="30000" anchor="ctr">
+                    <a:lnL w="0" cap="flat" cmpd="sng" algn="ctr">
+                      <a:solidFill>
+                        <a:srgbClr val="C9D9E8"/>
+                      </a:solidFill>
+                      <a:prstDash val="solid"/>
+                      <a:round/>
+                      <a:headEnd type="none" w="med" len="med"/>
+                      <a:tailEnd type="none" w="med" len="med"/>
+                    </a:lnL>
+                    <a:lnR w="0" cap="flat" cmpd="sng" algn="ctr">
+                      <a:solidFill>
+                        <a:srgbClr val="C9D9E8"/>
+                      </a:solidFill>
+                      <a:prstDash val="solid"/>
+                      <a:round/>
+                      <a:headEnd type="none" w="med" len="med"/>
+                      <a:tailEnd type="none" w="med" len="med"/>
+                    </a:lnR>
+                    <a:lnT w="0" cap="flat" cmpd="sng" algn="ctr">
+                      <a:solidFill>
+                        <a:srgbClr val="C9D9E8"/>
+                      </a:solidFill>
+                      <a:prstDash val="solid"/>
+                      <a:round/>
+                      <a:headEnd type="none" w="med" len="med"/>
+                      <a:tailEnd type="none" w="med" len="med"/>
+                    </a:lnT>
+                    <a:lnB w="9525" cap="flat" cmpd="sng" algn="ctr">
+                      <a:solidFill>
+                        <a:srgbClr val="C9D9E8"/>
+                      </a:solidFill>
+                      <a:prstDash val="solid"/>
+                      <a:round/>
+                      <a:headEnd type="none" w="med" len="med"/>
+                      <a:tailEnd type="none" w="med" len="med"/>
+                    </a:lnB>
+                    <a:solidFill>
+                      <a:srgbClr val="FFFFFF"/>
+                    </a:solidFill>
+                  </a:tcPr>
+                </a:tc>
+                <a:tc>
+                  <a:txBody>
+                    <a:bodyPr/>
+                    <a:lstStyle/>
+                    <a:p>
+                      <a:pPr marL="0" indent="0" algn="r">
+                        <a:buNone/>
+                      </a:pPr>
+                      <a:r>
                         <a:rPr lang="en-US" altLang="ko-KR" sz="1050" b="1" dirty="0" err="1">
                           <a:solidFill>
                             <a:srgbClr val="0E2240"/>
-                          </a:solidFill>
-                          <a:latin typeface="Noto Sans KR" pitchFamily="34" charset="0"/>
-                          <a:ea typeface="Noto Sans KR" pitchFamily="34" charset="-122"/>
-                          <a:cs typeface="Noto Sans KR" pitchFamily="34" charset="-120"/>
-                        </a:rPr>
-                        <a:t>66.0</a:t>
-                      </a:r>
-                      <a:endParaRPr lang="en-US" sz="1050" dirty="0">
-                        <a:latin typeface="Noto Sans KR" charset="0"/>
-                        <a:ea typeface="Noto Sans KR" charset="0"/>
-                        <a:cs typeface="Noto Sans KR" charset="0"/>
-                      </a:endParaRPr>
-                    </a:p>
-                  </a:txBody>
-                  <a:tcPr marL="152705" marR="152705" marT="30000" marB="30000" anchor="ctr">
-                    <a:lnL w="0" cap="flat" cmpd="sng" algn="ctr">
-                      <a:solidFill>
-                        <a:srgbClr val="C9D9E8"/>
-                      </a:solidFill>
-                      <a:prstDash val="solid"/>
-                      <a:round/>
-                      <a:headEnd type="none" w="med" len="med"/>
-                      <a:tailEnd type="none" w="med" len="med"/>
-                    </a:lnL>
-                    <a:lnR w="0" cap="flat" cmpd="sng" algn="ctr">
-                      <a:solidFill>
-                        <a:srgbClr val="C9D9E8"/>
-                      </a:solidFill>
-                      <a:prstDash val="solid"/>
-                      <a:round/>
-                      <a:headEnd type="none" w="med" len="med"/>
-                      <a:tailEnd type="none" w="med" len="med"/>
-                    </a:lnR>
-                    <a:lnT w="0" cap="flat" cmpd="sng" algn="ctr">
-                      <a:solidFill>
-                        <a:srgbClr val="C9D9E8"/>
-                      </a:solidFill>
-                      <a:prstDash val="solid"/>
-                      <a:round/>
-                      <a:headEnd type="none" w="med" len="med"/>
-                      <a:tailEnd type="none" w="med" len="med"/>
-                    </a:lnT>
-                    <a:lnB w="9525" cap="flat" cmpd="sng" algn="ctr">
-                      <a:solidFill>
-                        <a:srgbClr val="C9D9E8"/>
-                      </a:solidFill>
-                      <a:prstDash val="solid"/>
-                      <a:round/>
-                      <a:headEnd type="none" w="med" len="med"/>
-                      <a:tailEnd type="none" w="med" len="med"/>
-                    </a:lnB>
-                    <a:solidFill>
-                      <a:srgbClr val="FFFFFF"/>
-                    </a:solidFill>
-                  </a:tcPr>
-                </a:tc>
-                <a:tc>
-                  <a:txBody>
-                    <a:bodyPr/>
-                    <a:lstStyle/>
-                    <a:p>
-                      <a:pPr marL="0" indent="0" algn="r">
-                        <a:buNone/>
-                      </a:pPr>
-                      <a:r>
-                        <a:rPr lang="en-US" altLang="ko-KR" sz="1050" b="0" dirty="0" err="1">
-                          <a:solidFill>
-                            <a:srgbClr val="1F2A37"/>
                           </a:solidFill>
                           <a:latin typeface="Noto Sans KR" pitchFamily="34" charset="0"/>
                           <a:ea typeface="Noto Sans KR" pitchFamily="34" charset="-122"/>
@@ -14448,77 +14448,77 @@
                         <a:buNone/>
                       </a:pPr>
                       <a:r>
+                        <a:rPr lang="en-US" altLang="ko-KR" sz="1050" b="0" dirty="0" err="1">
+                          <a:solidFill>
+                            <a:srgbClr val="1F2A37"/>
+                          </a:solidFill>
+                          <a:latin typeface="Noto Sans KR" pitchFamily="34" charset="0"/>
+                          <a:ea typeface="Noto Sans KR" pitchFamily="34" charset="-122"/>
+                          <a:cs typeface="Noto Sans KR" pitchFamily="34" charset="-120"/>
+                        </a:rPr>
+                        <a:t>30.0</a:t>
+                      </a:r>
+                      <a:endParaRPr lang="en-US" sz="1050" dirty="0">
+                        <a:latin typeface="Noto Sans KR" charset="0"/>
+                        <a:ea typeface="Noto Sans KR" charset="0"/>
+                        <a:cs typeface="Noto Sans KR" charset="0"/>
+                      </a:endParaRPr>
+                    </a:p>
+                  </a:txBody>
+                  <a:tcPr marL="152705" marR="152705" marT="30000" marB="30000" anchor="ctr">
+                    <a:lnL w="0" cap="flat" cmpd="sng" algn="ctr">
+                      <a:solidFill>
+                        <a:srgbClr val="C9D9E8"/>
+                      </a:solidFill>
+                      <a:prstDash val="solid"/>
+                      <a:round/>
+                      <a:headEnd type="none" w="med" len="med"/>
+                      <a:tailEnd type="none" w="med" len="med"/>
+                    </a:lnL>
+                    <a:lnR w="0" cap="flat" cmpd="sng" algn="ctr">
+                      <a:solidFill>
+                        <a:srgbClr val="C9D9E8"/>
+                      </a:solidFill>
+                      <a:prstDash val="solid"/>
+                      <a:round/>
+                      <a:headEnd type="none" w="med" len="med"/>
+                      <a:tailEnd type="none" w="med" len="med"/>
+                    </a:lnR>
+                    <a:lnT w="0" cap="flat" cmpd="sng" algn="ctr">
+                      <a:solidFill>
+                        <a:srgbClr val="C9D9E8"/>
+                      </a:solidFill>
+                      <a:prstDash val="solid"/>
+                      <a:round/>
+                      <a:headEnd type="none" w="med" len="med"/>
+                      <a:tailEnd type="none" w="med" len="med"/>
+                    </a:lnT>
+                    <a:lnB w="9525" cap="flat" cmpd="sng" algn="ctr">
+                      <a:solidFill>
+                        <a:srgbClr val="C9D9E8"/>
+                      </a:solidFill>
+                      <a:prstDash val="solid"/>
+                      <a:round/>
+                      <a:headEnd type="none" w="med" len="med"/>
+                      <a:tailEnd type="none" w="med" len="med"/>
+                    </a:lnB>
+                    <a:solidFill>
+                      <a:srgbClr val="F7FAFD"/>
+                    </a:solidFill>
+                  </a:tcPr>
+                </a:tc>
+                <a:tc>
+                  <a:txBody>
+                    <a:bodyPr/>
+                    <a:lstStyle/>
+                    <a:p>
+                      <a:pPr marL="0" indent="0" algn="r">
+                        <a:buNone/>
+                      </a:pPr>
+                      <a:r>
                         <a:rPr lang="en-US" altLang="ko-KR" sz="1050" b="1" dirty="0" err="1">
                           <a:solidFill>
                             <a:srgbClr val="0E2240"/>
-                          </a:solidFill>
-                          <a:latin typeface="Noto Sans KR" pitchFamily="34" charset="0"/>
-                          <a:ea typeface="Noto Sans KR" pitchFamily="34" charset="-122"/>
-                          <a:cs typeface="Noto Sans KR" pitchFamily="34" charset="-120"/>
-                        </a:rPr>
-                        <a:t>30.0</a:t>
-                      </a:r>
-                      <a:endParaRPr lang="en-US" sz="1050" dirty="0">
-                        <a:latin typeface="Noto Sans KR" charset="0"/>
-                        <a:ea typeface="Noto Sans KR" charset="0"/>
-                        <a:cs typeface="Noto Sans KR" charset="0"/>
-                      </a:endParaRPr>
-                    </a:p>
-                  </a:txBody>
-                  <a:tcPr marL="152705" marR="152705" marT="30000" marB="30000" anchor="ctr">
-                    <a:lnL w="0" cap="flat" cmpd="sng" algn="ctr">
-                      <a:solidFill>
-                        <a:srgbClr val="C9D9E8"/>
-                      </a:solidFill>
-                      <a:prstDash val="solid"/>
-                      <a:round/>
-                      <a:headEnd type="none" w="med" len="med"/>
-                      <a:tailEnd type="none" w="med" len="med"/>
-                    </a:lnL>
-                    <a:lnR w="0" cap="flat" cmpd="sng" algn="ctr">
-                      <a:solidFill>
-                        <a:srgbClr val="C9D9E8"/>
-                      </a:solidFill>
-                      <a:prstDash val="solid"/>
-                      <a:round/>
-                      <a:headEnd type="none" w="med" len="med"/>
-                      <a:tailEnd type="none" w="med" len="med"/>
-                    </a:lnR>
-                    <a:lnT w="0" cap="flat" cmpd="sng" algn="ctr">
-                      <a:solidFill>
-                        <a:srgbClr val="C9D9E8"/>
-                      </a:solidFill>
-                      <a:prstDash val="solid"/>
-                      <a:round/>
-                      <a:headEnd type="none" w="med" len="med"/>
-                      <a:tailEnd type="none" w="med" len="med"/>
-                    </a:lnT>
-                    <a:lnB w="9525" cap="flat" cmpd="sng" algn="ctr">
-                      <a:solidFill>
-                        <a:srgbClr val="C9D9E8"/>
-                      </a:solidFill>
-                      <a:prstDash val="solid"/>
-                      <a:round/>
-                      <a:headEnd type="none" w="med" len="med"/>
-                      <a:tailEnd type="none" w="med" len="med"/>
-                    </a:lnB>
-                    <a:solidFill>
-                      <a:srgbClr val="F7FAFD"/>
-                    </a:solidFill>
-                  </a:tcPr>
-                </a:tc>
-                <a:tc>
-                  <a:txBody>
-                    <a:bodyPr/>
-                    <a:lstStyle/>
-                    <a:p>
-                      <a:pPr marL="0" indent="0" algn="r">
-                        <a:buNone/>
-                      </a:pPr>
-                      <a:r>
-                        <a:rPr lang="en-US" altLang="ko-KR" sz="1050" b="0" dirty="0" err="1">
-                          <a:solidFill>
-                            <a:srgbClr val="1F2A37"/>
                           </a:solidFill>
                           <a:latin typeface="Noto Sans KR" pitchFamily="34" charset="0"/>
                           <a:ea typeface="Noto Sans KR" pitchFamily="34" charset="-122"/>
@@ -14722,77 +14722,77 @@
                         <a:buNone/>
                       </a:pPr>
                       <a:r>
+                        <a:rPr lang="en-US" altLang="ko-KR" sz="1050" b="0" dirty="0" err="1">
+                          <a:solidFill>
+                            <a:srgbClr val="1F2A37"/>
+                          </a:solidFill>
+                          <a:latin typeface="Noto Sans KR" pitchFamily="34" charset="0"/>
+                          <a:ea typeface="Noto Sans KR" pitchFamily="34" charset="-122"/>
+                          <a:cs typeface="Noto Sans KR" pitchFamily="34" charset="-120"/>
+                        </a:rPr>
+                        <a:t>611.4</a:t>
+                      </a:r>
+                      <a:endParaRPr lang="en-US" sz="1050" dirty="0">
+                        <a:latin typeface="Noto Sans KR" charset="0"/>
+                        <a:ea typeface="Noto Sans KR" charset="0"/>
+                        <a:cs typeface="Noto Sans KR" charset="0"/>
+                      </a:endParaRPr>
+                    </a:p>
+                  </a:txBody>
+                  <a:tcPr marL="152705" marR="152705" marT="30000" marB="30000" anchor="ctr">
+                    <a:lnL w="0" cap="flat" cmpd="sng" algn="ctr">
+                      <a:solidFill>
+                        <a:srgbClr val="C9D9E8"/>
+                      </a:solidFill>
+                      <a:prstDash val="solid"/>
+                      <a:round/>
+                      <a:headEnd type="none" w="med" len="med"/>
+                      <a:tailEnd type="none" w="med" len="med"/>
+                    </a:lnL>
+                    <a:lnR w="0" cap="flat" cmpd="sng" algn="ctr">
+                      <a:solidFill>
+                        <a:srgbClr val="C9D9E8"/>
+                      </a:solidFill>
+                      <a:prstDash val="solid"/>
+                      <a:round/>
+                      <a:headEnd type="none" w="med" len="med"/>
+                      <a:tailEnd type="none" w="med" len="med"/>
+                    </a:lnR>
+                    <a:lnT w="0" cap="flat" cmpd="sng" algn="ctr">
+                      <a:solidFill>
+                        <a:srgbClr val="C9D9E8"/>
+                      </a:solidFill>
+                      <a:prstDash val="solid"/>
+                      <a:round/>
+                      <a:headEnd type="none" w="med" len="med"/>
+                      <a:tailEnd type="none" w="med" len="med"/>
+                    </a:lnT>
+                    <a:lnB w="9525" cap="flat" cmpd="sng" algn="ctr">
+                      <a:solidFill>
+                        <a:srgbClr val="C9D9E8"/>
+                      </a:solidFill>
+                      <a:prstDash val="solid"/>
+                      <a:round/>
+                      <a:headEnd type="none" w="med" len="med"/>
+                      <a:tailEnd type="none" w="med" len="med"/>
+                    </a:lnB>
+                    <a:solidFill>
+                      <a:srgbClr val="DDE9F4"/>
+                    </a:solidFill>
+                  </a:tcPr>
+                </a:tc>
+                <a:tc>
+                  <a:txBody>
+                    <a:bodyPr/>
+                    <a:lstStyle/>
+                    <a:p>
+                      <a:pPr marL="0" indent="0" algn="r">
+                        <a:buNone/>
+                      </a:pPr>
+                      <a:r>
                         <a:rPr lang="en-US" altLang="ko-KR" sz="1050" b="1" dirty="0" err="1">
                           <a:solidFill>
                             <a:srgbClr val="B8860B"/>
-                          </a:solidFill>
-                          <a:latin typeface="Noto Sans KR" pitchFamily="34" charset="0"/>
-                          <a:ea typeface="Noto Sans KR" pitchFamily="34" charset="-122"/>
-                          <a:cs typeface="Noto Sans KR" pitchFamily="34" charset="-120"/>
-                        </a:rPr>
-                        <a:t>611.4</a:t>
-                      </a:r>
-                      <a:endParaRPr lang="en-US" sz="1050" dirty="0">
-                        <a:latin typeface="Noto Sans KR" charset="0"/>
-                        <a:ea typeface="Noto Sans KR" charset="0"/>
-                        <a:cs typeface="Noto Sans KR" charset="0"/>
-                      </a:endParaRPr>
-                    </a:p>
-                  </a:txBody>
-                  <a:tcPr marL="152705" marR="152705" marT="30000" marB="30000" anchor="ctr">
-                    <a:lnL w="0" cap="flat" cmpd="sng" algn="ctr">
-                      <a:solidFill>
-                        <a:srgbClr val="C9D9E8"/>
-                      </a:solidFill>
-                      <a:prstDash val="solid"/>
-                      <a:round/>
-                      <a:headEnd type="none" w="med" len="med"/>
-                      <a:tailEnd type="none" w="med" len="med"/>
-                    </a:lnL>
-                    <a:lnR w="0" cap="flat" cmpd="sng" algn="ctr">
-                      <a:solidFill>
-                        <a:srgbClr val="C9D9E8"/>
-                      </a:solidFill>
-                      <a:prstDash val="solid"/>
-                      <a:round/>
-                      <a:headEnd type="none" w="med" len="med"/>
-                      <a:tailEnd type="none" w="med" len="med"/>
-                    </a:lnR>
-                    <a:lnT w="0" cap="flat" cmpd="sng" algn="ctr">
-                      <a:solidFill>
-                        <a:srgbClr val="C9D9E8"/>
-                      </a:solidFill>
-                      <a:prstDash val="solid"/>
-                      <a:round/>
-                      <a:headEnd type="none" w="med" len="med"/>
-                      <a:tailEnd type="none" w="med" len="med"/>
-                    </a:lnT>
-                    <a:lnB w="9525" cap="flat" cmpd="sng" algn="ctr">
-                      <a:solidFill>
-                        <a:srgbClr val="C9D9E8"/>
-                      </a:solidFill>
-                      <a:prstDash val="solid"/>
-                      <a:round/>
-                      <a:headEnd type="none" w="med" len="med"/>
-                      <a:tailEnd type="none" w="med" len="med"/>
-                    </a:lnB>
-                    <a:solidFill>
-                      <a:srgbClr val="DDE9F4"/>
-                    </a:solidFill>
-                  </a:tcPr>
-                </a:tc>
-                <a:tc>
-                  <a:txBody>
-                    <a:bodyPr/>
-                    <a:lstStyle/>
-                    <a:p>
-                      <a:pPr marL="0" indent="0" algn="r">
-                        <a:buNone/>
-                      </a:pPr>
-                      <a:r>
-                        <a:rPr lang="en-US" altLang="ko-KR" sz="1050" b="1" dirty="0" err="1">
-                          <a:solidFill>
-                            <a:srgbClr val="1F2A37"/>
                           </a:solidFill>
                           <a:latin typeface="Noto Sans KR" pitchFamily="34" charset="0"/>
                           <a:ea typeface="Noto Sans KR" pitchFamily="34" charset="-122"/>
@@ -15091,7 +15091,7 @@
                 <a:latin typeface="Noto Sans KR"/>
                 <a:ea typeface="Noto Sans KR"/>
               </a:rPr>
-              <a:t>빌트인 쿡탑·냉장고·세탁기가 옵션이면 최대 179만 원 감소</a:t>
+              <a:t>빌트인 쿡탑·냉장고·세탁기가 옵션이면 최대 206만 원 감소</a:t>
             </a:r>
           </a:p>
           <a:p>
@@ -15108,7 +15108,7 @@
                 <a:latin typeface="Noto Sans KR"/>
                 <a:ea typeface="Noto Sans KR"/>
               </a:rPr>
-              <a:t>표준안 숙소 </a:t>
+              <a:t>실속안 숙소 </a:t>
             </a:r>
             <a:r>
               <a:rPr sz="1100" b="0">
@@ -15118,7 +15118,7 @@
                 <a:latin typeface="Noto Sans KR"/>
                 <a:ea typeface="Noto Sans KR"/>
               </a:rPr>
-              <a:t>1,041만 원 — 품의는 실속안 기준, 차액은 예비비로 흡수하지 않음</a:t>
+              <a:t>611만 원 — 품의는 표준안 기준, 실속안 집행 시 430만 원 절감</a:t>
             </a:r>
           </a:p>
         </p:txBody>
@@ -24479,7 +24479,7 @@
                 <a:ea typeface="Noto Sans KR" pitchFamily="34" charset="-122"/>
                 <a:cs typeface="Noto Sans KR" pitchFamily="34" charset="-120"/>
               </a:rPr>
-              <a:t>2026 현금 8,243만 원</a:t>
+              <a:t>2026 현금 8,673만 원</a:t>
             </a:r>
             <a:r>
               <a:rPr lang="en-US" sz="3150" b="1" kern="0" spc="-31" dirty="0">
@@ -24920,7 +24920,7 @@
                 <a:latin typeface="Noto Sans KR"/>
                 <a:ea typeface="Noto Sans KR"/>
               </a:rPr>
-              <a:t>2,890.8</a:t>
+              <a:t>3,320.8</a:t>
             </a:r>
             <a:r>
               <a:rPr sz="1200" b="1">
@@ -25002,7 +25002,7 @@
                 <a:latin typeface="Noto Sans KR"/>
                 <a:ea typeface="Noto Sans KR"/>
               </a:rPr>
-              <a:t>일회성 1,942.6 + 운영 948.1</a:t>
+              <a:t>일회성 2,372.6 + 운영 948.1</a:t>
             </a:r>
           </a:p>
         </p:txBody>
@@ -25252,7 +25252,7 @@
                 <a:latin typeface="Noto Sans KR"/>
                 <a:ea typeface="Noto Sans KR"/>
               </a:rPr>
-              <a:t>8,243.0</a:t>
+              <a:t>8,673.0</a:t>
             </a:r>
             <a:r>
               <a:rPr sz="1200" b="1">
@@ -26978,7 +26978,7 @@
                           <a:ea typeface="Noto Sans KR" pitchFamily="34" charset="-122"/>
                           <a:cs typeface="Noto Sans KR" pitchFamily="34" charset="-120"/>
                         </a:rPr>
-                        <a:t>1,100</a:t>
+                        <a:t>1,541</a:t>
                       </a:r>
                       <a:endParaRPr lang="en-US" sz="1050" dirty="0">
                         <a:latin typeface="Noto Sans KR" charset="0"/>
@@ -27046,7 +27046,7 @@
                           <a:ea typeface="Noto Sans KR" pitchFamily="34" charset="-122"/>
                           <a:cs typeface="Noto Sans KR" pitchFamily="34" charset="-120"/>
                         </a:rPr>
-                        <a:t>1,942.6</a:t>
+                        <a:t>2,372.6</a:t>
                       </a:r>
                       <a:endParaRPr lang="en-US" sz="1050" dirty="0">
                         <a:latin typeface="Noto Sans KR" charset="0"/>
@@ -27114,7 +27114,7 @@
                           <a:ea typeface="Noto Sans KR" pitchFamily="34" charset="-122"/>
                           <a:cs typeface="Noto Sans KR" pitchFamily="34" charset="-120"/>
                         </a:rPr>
-                        <a:t>+842.6</a:t>
+                        <a:t>+831.2</a:t>
                       </a:r>
                       <a:endParaRPr lang="en-US" sz="1050" dirty="0">
                         <a:latin typeface="Noto Sans KR" charset="0"/>
@@ -27182,7 +27182,7 @@
                           <a:ea typeface="Noto Sans KR" pitchFamily="34" charset="-122"/>
                           <a:cs typeface="Noto Sans KR" pitchFamily="34" charset="-120"/>
                         </a:rPr>
-                        <a:t>계획서 0.11억에 사무 집기가 빠져 있음</a:t>
+                        <a:t>계획서 0.15억에 사무 집기가 빠져 있음</a:t>
                       </a:r>
                       <a:endParaRPr lang="en-US" sz="1050" dirty="0">
                         <a:latin typeface="Noto Sans KR" charset="0"/>
@@ -28473,7 +28473,7 @@
                 <a:latin typeface="Noto Sans KR"/>
                 <a:ea typeface="Noto Sans KR"/>
               </a:rPr>
-              <a:t>2026 일회성 0.11억 → 0.19억 반영 시 2026 거점 영업손익 (0.33) → 약 (0.42)억</a:t>
+              <a:t>2026 일회성 0.15억 → 0.24억 반영 시 2026 거점 영업손익 (0.38) → 약 (0.46)억</a:t>
             </a:r>
           </a:p>
           <a:p>
@@ -28715,7 +28715,7 @@
                 <a:latin typeface="Noto Sans KR"/>
                 <a:ea typeface="Noto Sans KR"/>
               </a:rPr>
-              <a:t>빌트인 쿡탑·냉장고·세탁기 포함 여부 (최대 179 감소)</a:t>
+              <a:t>빌트인 쿡탑·냉장고·세탁기 포함 여부 (최대 206 감소)</a:t>
             </a:r>
           </a:p>
           <a:p>

</xml_diff>

<commit_message>
Reflect office furniture in plan v11 one-time cost; sync approval docs
Co-Authored-By: Claude Opus 5.5 <noreply@anthropic.com>
Claude-Session: https://claude.ai/code/session_01SrTScNKmsHS34birk48N5j
</commit_message>
<xml_diff>
--- a/output/changwon_budget_request_attachment.pptx
+++ b/output/changwon_budget_request_attachment.pptx
@@ -26636,7 +26636,7 @@
                           <a:ea typeface="Noto Sans KR" pitchFamily="34" charset="-122"/>
                           <a:cs typeface="Noto Sans KR" pitchFamily="34" charset="-120"/>
                         </a:rPr>
-                        <a:t>900~1,200</a:t>
+                        <a:t>1,331.2</a:t>
                       </a:r>
                       <a:endParaRPr lang="en-US" sz="1050" dirty="0">
                         <a:latin typeface="Noto Sans KR" charset="0"/>
@@ -26772,7 +26772,7 @@
                           <a:ea typeface="Noto Sans KR" pitchFamily="34" charset="-122"/>
                           <a:cs typeface="Noto Sans KR" pitchFamily="34" charset="-120"/>
                         </a:rPr>
-                        <a:t>+131~431</a:t>
+                        <a:t>0</a:t>
                       </a:r>
                       <a:endParaRPr lang="en-US" sz="1050" dirty="0">
                         <a:latin typeface="Noto Sans KR" charset="0"/>
@@ -26840,7 +26840,7 @@
                           <a:ea typeface="Noto Sans KR" pitchFamily="34" charset="-122"/>
                           <a:cs typeface="Noto Sans KR" pitchFamily="34" charset="-120"/>
                         </a:rPr>
-                        <a:t>68개 품목 체크리스트 + 예비비 10%</a:t>
+                        <a:t>반영 완료 — 체크리스트 표준안 + 예비비 10%</a:t>
                       </a:r>
                       <a:endParaRPr lang="en-US" sz="1050" dirty="0">
                         <a:latin typeface="Noto Sans KR" charset="0"/>
@@ -26978,7 +26978,7 @@
                           <a:ea typeface="Noto Sans KR" pitchFamily="34" charset="-122"/>
                           <a:cs typeface="Noto Sans KR" pitchFamily="34" charset="-120"/>
                         </a:rPr>
-                        <a:t>1,541</a:t>
+                        <a:t>2,372.6</a:t>
                       </a:r>
                       <a:endParaRPr lang="en-US" sz="1050" dirty="0">
                         <a:latin typeface="Noto Sans KR" charset="0"/>
@@ -27114,7 +27114,7 @@
                           <a:ea typeface="Noto Sans KR" pitchFamily="34" charset="-122"/>
                           <a:cs typeface="Noto Sans KR" pitchFamily="34" charset="-120"/>
                         </a:rPr>
-                        <a:t>+831.2</a:t>
+                        <a:t>0</a:t>
                       </a:r>
                       <a:endParaRPr lang="en-US" sz="1050" dirty="0">
                         <a:latin typeface="Noto Sans KR" charset="0"/>
@@ -27182,7 +27182,7 @@
                           <a:ea typeface="Noto Sans KR" pitchFamily="34" charset="-122"/>
                           <a:cs typeface="Noto Sans KR" pitchFamily="34" charset="-120"/>
                         </a:rPr>
-                        <a:t>계획서 0.15억에 사무 집기가 빠져 있음</a:t>
+                        <a:t>반영 완료 — 사무 집기 + 숙소 설치 (0.24억)</a:t>
                       </a:r>
                       <a:endParaRPr lang="en-US" sz="1050" dirty="0">
                         <a:latin typeface="Noto Sans KR" charset="0"/>
@@ -28446,7 +28446,7 @@
                 <a:latin typeface="Noto Sans KR"/>
                 <a:ea typeface="Noto Sans KR"/>
               </a:rPr>
-              <a:t>계획서 반영 필요</a:t>
+              <a:t>계획서 반영 현황</a:t>
             </a:r>
           </a:p>
           <a:p>
@@ -28473,7 +28473,7 @@
                 <a:latin typeface="Noto Sans KR"/>
                 <a:ea typeface="Noto Sans KR"/>
               </a:rPr>
-              <a:t>2026 일회성 0.15억 → 0.24억 반영 시 2026 거점 영업손익 (0.38) → 약 (0.46)억</a:t>
+              <a:t>반영 완료 — 2026 일회성 0.24억, 2026 거점 영업손익 (0.46)억, 3개년 +7.33억</a:t>
             </a:r>
           </a:p>
           <a:p>
@@ -28500,7 +28500,7 @@
                 <a:latin typeface="Noto Sans KR"/>
                 <a:ea typeface="Noto Sans KR"/>
               </a:rPr>
-              <a:t>사무실 운영비 월 70만 → 월 고정비 111.07만(임대료 포함)으로 정리</a:t>
+              <a:t>미반영 — 사무실 운영비 월 70만 vs 월 고정비 111.07만(임대료 포함)</a:t>
             </a:r>
           </a:p>
           <a:p>
@@ -28527,7 +28527,7 @@
                 <a:latin typeface="Noto Sans KR"/>
                 <a:ea typeface="Noto Sans KR"/>
               </a:rPr>
-              <a:t>사무 집기 900~1,200 → 1,331 (표준안)으로 갱신</a:t>
+              <a:t>반영 완료 — 사무 집기 1,331 (표준안)</a:t>
             </a:r>
           </a:p>
         </p:txBody>

</xml_diff>

<commit_message>
Align v11 office costs with approval request; replace cover graphic with stylized access map
Co-Authored-By: Claude Opus 5.5 <noreply@anthropic.com>
Claude-Session: https://claude.ai/code/session_01SrTScNKmsHS34birk48N5j
</commit_message>
<xml_diff>
--- a/output/changwon_budget_request_attachment.pptx
+++ b/output/changwon_budget_request_attachment.pptx
@@ -1227,171 +1227,6 @@
       </p:pic>
       <p:sp>
         <p:nvSpPr>
-          <p:cNvPr id="5" name="Shape 0"/>
-          <p:cNvSpPr/>
-          <p:nvPr/>
-        </p:nvSpPr>
-        <p:spPr>
-          <a:xfrm>
-            <a:off x="13144500" y="2095805"/>
-            <a:ext cx="4953305" cy="4953305"/>
-          </a:xfrm>
-          <a:prstGeom prst="ellipse">
-            <a:avLst/>
-          </a:prstGeom>
-          <a:noFill/>
-          <a:ln w="12700">
-            <a:solidFill>
-              <a:srgbClr val="B8860B">
-                <a:alpha val="35000"/>
-              </a:srgbClr>
-            </a:solidFill>
-            <a:prstDash val="solid"/>
-          </a:ln>
-        </p:spPr>
-        <p:txBody>
-          <a:bodyPr/>
-          <a:lstStyle/>
-          <a:p>
-            <a:endParaRPr lang="ko-KR" altLang="en-US"/>
-          </a:p>
-        </p:txBody>
-      </p:sp>
-      <p:sp>
-        <p:nvSpPr>
-          <p:cNvPr id="6" name="Shape 1"/>
-          <p:cNvSpPr/>
-          <p:nvPr/>
-        </p:nvSpPr>
-        <p:spPr>
-          <a:xfrm>
-            <a:off x="13716000" y="2667305"/>
-            <a:ext cx="3810305" cy="3810305"/>
-          </a:xfrm>
-          <a:prstGeom prst="ellipse">
-            <a:avLst/>
-          </a:prstGeom>
-          <a:noFill/>
-          <a:ln w="12700">
-            <a:solidFill>
-              <a:srgbClr val="B8860B">
-                <a:alpha val="50000"/>
-              </a:srgbClr>
-            </a:solidFill>
-            <a:prstDash val="solid"/>
-          </a:ln>
-        </p:spPr>
-        <p:txBody>
-          <a:bodyPr/>
-          <a:lstStyle/>
-          <a:p>
-            <a:endParaRPr lang="ko-KR" altLang="en-US"/>
-          </a:p>
-        </p:txBody>
-      </p:sp>
-      <p:sp>
-        <p:nvSpPr>
-          <p:cNvPr id="7" name="Shape 2"/>
-          <p:cNvSpPr/>
-          <p:nvPr/>
-        </p:nvSpPr>
-        <p:spPr>
-          <a:xfrm>
-            <a:off x="14477695" y="3429000"/>
-            <a:ext cx="2286000" cy="2286000"/>
-          </a:xfrm>
-          <a:prstGeom prst="ellipse">
-            <a:avLst/>
-          </a:prstGeom>
-          <a:noFill/>
-          <a:ln w="12700">
-            <a:solidFill>
-              <a:srgbClr val="E2B23A">
-                <a:alpha val="70000"/>
-              </a:srgbClr>
-            </a:solidFill>
-            <a:prstDash val="solid"/>
-          </a:ln>
-        </p:spPr>
-        <p:txBody>
-          <a:bodyPr/>
-          <a:lstStyle/>
-          <a:p>
-            <a:endParaRPr lang="ko-KR" altLang="en-US"/>
-          </a:p>
-        </p:txBody>
-      </p:sp>
-      <p:pic>
-        <p:nvPicPr>
-          <p:cNvPr id="8" name="Image 3" descr="gen-dedup-d6659cdc35e2f31f8645301e667090c5.png"/>
-          <p:cNvPicPr>
-            <a:picLocks noChangeAspect="1"/>
-          </p:cNvPicPr>
-          <p:nvPr/>
-        </p:nvPicPr>
-        <p:blipFill>
-          <a:blip r:embed="rId6"/>
-          <a:srcRect/>
-          <a:stretch/>
-        </p:blipFill>
-        <p:spPr>
-          <a:xfrm>
-            <a:off x="15049195" y="4000500"/>
-            <a:ext cx="1143000" cy="1143000"/>
-          </a:xfrm>
-          <a:prstGeom prst="rect">
-            <a:avLst/>
-          </a:prstGeom>
-        </p:spPr>
-      </p:pic>
-      <p:pic>
-        <p:nvPicPr>
-          <p:cNvPr id="9" name="Image 4" descr="gen-dedup-c54f620b4818ddb68cc679f84e1874a1.png"/>
-          <p:cNvPicPr>
-            <a:picLocks noChangeAspect="1"/>
-          </p:cNvPicPr>
-          <p:nvPr/>
-        </p:nvPicPr>
-        <p:blipFill>
-          <a:blip r:embed="rId7"/>
-          <a:srcRect/>
-          <a:stretch/>
-        </p:blipFill>
-        <p:spPr>
-          <a:xfrm>
-            <a:off x="13144500" y="2095805"/>
-            <a:ext cx="5143500" cy="5143500"/>
-          </a:xfrm>
-          <a:prstGeom prst="rect">
-            <a:avLst/>
-          </a:prstGeom>
-        </p:spPr>
-      </p:pic>
-      <p:pic>
-        <p:nvPicPr>
-          <p:cNvPr id="10" name="Image 5" descr="gen-dedup-17d777abac9171ac847998b957fa702c.png"/>
-          <p:cNvPicPr>
-            <a:picLocks noChangeAspect="1"/>
-          </p:cNvPicPr>
-          <p:nvPr/>
-        </p:nvPicPr>
-        <p:blipFill>
-          <a:blip r:embed="rId8"/>
-          <a:srcRect t="-10" b="-10"/>
-          <a:stretch/>
-        </p:blipFill>
-        <p:spPr>
-          <a:xfrm>
-            <a:off x="12859207" y="7048195"/>
-            <a:ext cx="4572000" cy="1524305"/>
-          </a:xfrm>
-          <a:prstGeom prst="rect">
-            <a:avLst/>
-          </a:prstGeom>
-        </p:spPr>
-      </p:pic>
-      <p:sp>
-        <p:nvSpPr>
           <p:cNvPr id="11" name="Text 3"/>
           <p:cNvSpPr txBox="1"/>
           <p:nvPr/>
@@ -1720,6 +1555,30 @@
           </a:p>
         </p:txBody>
       </p:sp>
+      <p:pic>
+        <p:nvPicPr>
+          <p:cNvPr id="19" name="Cover Map" descr="cover_map.png"/>
+          <p:cNvPicPr>
+            <a:picLocks noChangeAspect="1"/>
+          </p:cNvPicPr>
+          <p:nvPr/>
+        </p:nvPicPr>
+        <p:blipFill>
+          <a:blip r:embed="rId10"/>
+          <a:stretch>
+            <a:fillRect/>
+          </a:stretch>
+        </p:blipFill>
+        <p:spPr>
+          <a:xfrm>
+            <a:off x="9088000" y="1532243"/>
+            <a:ext cx="8900000" cy="7222513"/>
+          </a:xfrm>
+          <a:prstGeom prst="rect">
+            <a:avLst/>
+          </a:prstGeom>
+        </p:spPr>
+      </p:pic>
     </p:spTree>
   </p:cSld>
   <p:clrMapOvr>
@@ -25952,7 +25811,7 @@
                           <a:ea typeface="Noto Sans KR" pitchFamily="34" charset="-122"/>
                           <a:cs typeface="Noto Sans KR" pitchFamily="34" charset="-120"/>
                         </a:rPr>
-                        <a:t>1,256.0</a:t>
+                        <a:t>1,333.0</a:t>
                       </a:r>
                       <a:endParaRPr lang="en-US" sz="1050" dirty="0">
                         <a:latin typeface="Noto Sans KR" charset="0"/>
@@ -26088,7 +25947,7 @@
                           <a:ea typeface="Noto Sans KR" pitchFamily="34" charset="-122"/>
                           <a:cs typeface="Noto Sans KR" pitchFamily="34" charset="-120"/>
                         </a:rPr>
-                        <a:t>+76.8</a:t>
+                        <a:t>0</a:t>
                       </a:r>
                       <a:endParaRPr lang="en-US" sz="1050" dirty="0">
                         <a:latin typeface="Noto Sans KR" charset="0"/>
@@ -26156,7 +26015,7 @@
                           <a:ea typeface="Noto Sans KR" pitchFamily="34" charset="-122"/>
                           <a:cs typeface="Noto Sans KR" pitchFamily="34" charset="-120"/>
                         </a:rPr>
-                        <a:t>임대료 VAT 포함, 렌탈·보안·탕비 소모품 세분화</a:t>
+                        <a:t>반영 완료 — 임대료 458(VAT 포함) + 운영비 875</a:t>
                       </a:r>
                       <a:endParaRPr lang="en-US" sz="1050" dirty="0">
                         <a:latin typeface="Noto Sans KR" charset="0"/>
@@ -26294,7 +26153,7 @@
                           <a:ea typeface="Noto Sans KR" pitchFamily="34" charset="-122"/>
                           <a:cs typeface="Noto Sans KR" pitchFamily="34" charset="-120"/>
                         </a:rPr>
-                        <a:t>170.0</a:t>
+                        <a:t>222.0</a:t>
                       </a:r>
                       <a:endParaRPr lang="en-US" sz="1050" dirty="0">
                         <a:latin typeface="Noto Sans KR" charset="0"/>
@@ -26430,7 +26289,7 @@
                           <a:ea typeface="Noto Sans KR" pitchFamily="34" charset="-122"/>
                           <a:cs typeface="Noto Sans KR" pitchFamily="34" charset="-120"/>
                         </a:rPr>
-                        <a:t>+52.1</a:t>
+                        <a:t>0</a:t>
                       </a:r>
                       <a:endParaRPr lang="en-US" sz="1050" dirty="0">
                         <a:latin typeface="Noto Sans KR" charset="0"/>
@@ -26498,7 +26357,7 @@
                           <a:ea typeface="Noto Sans KR" pitchFamily="34" charset="-122"/>
                           <a:cs typeface="Noto Sans KR" pitchFamily="34" charset="-120"/>
                         </a:rPr>
-                        <a:t>2026 운영비 월 50 → 월 고정비 111.07 적용</a:t>
+                        <a:t>반영 완료 — 임대료 76 + 운영비 146</a:t>
                       </a:r>
                       <a:endParaRPr lang="en-US" sz="1050" dirty="0">
                         <a:latin typeface="Noto Sans KR" charset="0"/>
@@ -27320,7 +27179,7 @@
                           <a:ea typeface="Noto Sans KR" pitchFamily="34" charset="-122"/>
                           <a:cs typeface="Noto Sans KR" pitchFamily="34" charset="-120"/>
                         </a:rPr>
-                        <a:t>731.0</a:t>
+                        <a:t>783.0</a:t>
                       </a:r>
                       <a:endParaRPr lang="en-US" sz="1050" dirty="0">
                         <a:latin typeface="Noto Sans KR" charset="0"/>
@@ -27456,7 +27315,7 @@
                           <a:ea typeface="Noto Sans KR" pitchFamily="34" charset="-122"/>
                           <a:cs typeface="Noto Sans KR" pitchFamily="34" charset="-120"/>
                         </a:rPr>
-                        <a:t>+52.3</a:t>
+                        <a:t>단수</a:t>
                       </a:r>
                       <a:endParaRPr lang="en-US" sz="1050" dirty="0">
                         <a:latin typeface="Noto Sans KR" charset="0"/>
@@ -27524,7 +27383,7 @@
                           <a:ea typeface="Noto Sans KR" pitchFamily="34" charset="-122"/>
                           <a:cs typeface="Noto Sans KR" pitchFamily="34" charset="-120"/>
                         </a:rPr>
-                        <a:t>사무실 월 고정비 차이</a:t>
+                        <a:t>출장비 절감 165 vs 164.8 반올림 차이</a:t>
                       </a:r>
                       <a:endParaRPr lang="en-US" sz="1050" dirty="0">
                         <a:latin typeface="Noto Sans KR" charset="0"/>
@@ -27662,7 +27521,7 @@
                           <a:ea typeface="Noto Sans KR" pitchFamily="34" charset="-122"/>
                           <a:cs typeface="Noto Sans KR" pitchFamily="34" charset="-120"/>
                         </a:rPr>
-                        <a:t>4,768.0</a:t>
+                        <a:t>4,845.0</a:t>
                       </a:r>
                       <a:endParaRPr lang="en-US" sz="1050" dirty="0">
                         <a:latin typeface="Noto Sans KR" charset="0"/>
@@ -27798,7 +27657,7 @@
                           <a:ea typeface="Noto Sans KR" pitchFamily="34" charset="-122"/>
                           <a:cs typeface="Noto Sans KR" pitchFamily="34" charset="-120"/>
                         </a:rPr>
-                        <a:t>+77.2</a:t>
+                        <a:t>단수</a:t>
                       </a:r>
                       <a:endParaRPr lang="en-US" sz="1050" dirty="0">
                         <a:latin typeface="Noto Sans KR" charset="0"/>
@@ -27866,7 +27725,7 @@
                           <a:ea typeface="Noto Sans KR" pitchFamily="34" charset="-122"/>
                           <a:cs typeface="Noto Sans KR" pitchFamily="34" charset="-120"/>
                         </a:rPr>
-                        <a:t>사무실 월 고정비 차이</a:t>
+                        <a:t>출장비 절감 1,978 vs 1,977.6 반올림 차이</a:t>
                       </a:r>
                       <a:endParaRPr lang="en-US" sz="1050" dirty="0">
                         <a:latin typeface="Noto Sans KR" charset="0"/>
@@ -27955,7 +27814,7 @@
                 <a:ea typeface="Noto Sans KR" pitchFamily="34" charset="-122"/>
                 <a:cs typeface="Noto Sans KR" pitchFamily="34" charset="-120"/>
               </a:rPr>
-              <a:t>계획서(v11) 대비 </a:t>
+              <a:t>계획서(v11) </a:t>
             </a:r>
             <a:r>
               <a:rPr lang="en-US" sz="3150" b="1" kern="0" spc="-31" dirty="0">
@@ -27966,7 +27825,7 @@
                 <a:ea typeface="Noto Sans KR" pitchFamily="34" charset="-122"/>
                 <a:cs typeface="Noto Sans KR" pitchFamily="34" charset="-120"/>
               </a:rPr>
-              <a:t>차이와 확인 사항</a:t>
+              <a:t>정합성과 확인 사항</a:t>
             </a:r>
             <a:endParaRPr lang="en-US" sz="3150" dirty="0"/>
           </a:p>
@@ -28005,7 +27864,7 @@
                 <a:ea typeface="Noto Sans KR" pitchFamily="34" charset="-122"/>
                 <a:cs typeface="Noto Sans KR" pitchFamily="34" charset="-120"/>
               </a:rPr>
-              <a:t>본 품의는 사무소 물품 체크리스트 · 월 고정비 · 주거비 상세를 반영한 집행 기준 — 계획서의 추정치보다 정밀함</a:t>
+              <a:t>본 품의 금액은 계획서 v11의 A2 산출표 · 08쪽 손익과 일치 — 만 원 미만 단수 차이만 있음</a:t>
             </a:r>
             <a:endParaRPr lang="en-US" sz="1500" dirty="0"/>
           </a:p>
@@ -28080,7 +27939,7 @@
                 <a:ea typeface="Noto Sans KR" pitchFamily="34" charset="-122"/>
                 <a:cs typeface="Noto Sans KR" pitchFamily="34" charset="-120"/>
               </a:rPr>
-              <a:t>계획서 대비 차이</a:t>
+              <a:t>계획서 v11과 대조</a:t>
             </a:r>
             <a:endParaRPr lang="en-US" sz="1650" dirty="0"/>
           </a:p>
@@ -28094,7 +27953,7 @@
         </p:nvSpPr>
         <p:spPr>
           <a:xfrm>
-            <a:off x="3324595" y="1616577"/>
+            <a:off x="3784595" y="1616577"/>
             <a:ext cx="4000000" cy="247802"/>
           </a:xfrm>
           <a:prstGeom prst="rect">
@@ -28473,7 +28332,7 @@
                 <a:latin typeface="Noto Sans KR"/>
                 <a:ea typeface="Noto Sans KR"/>
               </a:rPr>
-              <a:t>반영 완료 — 2026 일회성 0.24억, 2026 거점 영업손익 (0.46)억, 3개년 +7.33억</a:t>
+              <a:t>반영 완료 — 2026 일회성 0.24억, 2026 거점 영업손익 (0.47)억, 3개년 +7.31억</a:t>
             </a:r>
           </a:p>
           <a:p>
@@ -28500,7 +28359,7 @@
                 <a:latin typeface="Noto Sans KR"/>
                 <a:ea typeface="Noto Sans KR"/>
               </a:rPr>
-              <a:t>미반영 — 사무실 운영비 월 70만 vs 월 고정비 111.07만(임대료 포함)</a:t>
+              <a:t>반영 완료 — 사무실 월 111.07만(임대료 VAT 포함), 2027 경비 순증 0.48억</a:t>
             </a:r>
           </a:p>
           <a:p>

</xml_diff>

<commit_message>
Relabel cover map center to 경남 창원
Co-Authored-By: Claude Opus 5.5 <noreply@anthropic.com>
Claude-Session: https://claude.ai/code/session_01SrTScNKmsHS34birk48N5j
</commit_message>
<xml_diff>
--- a/output/changwon_budget_request_attachment.pptx
+++ b/output/changwon_budget_request_attachment.pptx
@@ -1587,7 +1587,7 @@
 </p:sld>
 </file>
 
-<file path=ppt/slides/slide21.xml><?xml version="1.0" encoding="utf-8"?>
+<file path=ppt/slides/slide2.xml><?xml version="1.0" encoding="utf-8"?>
 <p:sld xmlns:a="http://schemas.openxmlformats.org/drawingml/2006/main" xmlns:p="http://schemas.openxmlformats.org/presentationml/2006/main" xmlns:r="http://schemas.openxmlformats.org/officeDocument/2006/relationships">
   <p:cSld>
     <p:spTree>
@@ -7006,7 +7006,7 @@
 </p:sld>
 </file>
 
-<file path=ppt/slides/slide22.xml><?xml version="1.0" encoding="utf-8"?>
+<file path=ppt/slides/slide3.xml><?xml version="1.0" encoding="utf-8"?>
 <p:sld xmlns:a="http://schemas.openxmlformats.org/drawingml/2006/main" xmlns:p="http://schemas.openxmlformats.org/presentationml/2006/main" xmlns:r="http://schemas.openxmlformats.org/officeDocument/2006/relationships">
   <p:cSld>
     <p:spTree>
@@ -14990,7 +14990,7 @@
 </p:sld>
 </file>
 
-<file path=ppt/slides/slide23.xml><?xml version="1.0" encoding="utf-8"?>
+<file path=ppt/slides/slide4.xml><?xml version="1.0" encoding="utf-8"?>
 <p:sld xmlns:a="http://schemas.openxmlformats.org/drawingml/2006/main" xmlns:p="http://schemas.openxmlformats.org/presentationml/2006/main" xmlns:r="http://schemas.openxmlformats.org/officeDocument/2006/relationships">
   <p:cSld>
     <p:spTree>
@@ -22584,7 +22584,7 @@
 </p:sld>
 </file>
 
-<file path=ppt/slides/slide24.xml><?xml version="1.0" encoding="utf-8"?>
+<file path=ppt/slides/slide5.xml><?xml version="1.0" encoding="utf-8"?>
 <p:sld xmlns:a="http://schemas.openxmlformats.org/drawingml/2006/main" xmlns:p="http://schemas.openxmlformats.org/presentationml/2006/main" xmlns:r="http://schemas.openxmlformats.org/officeDocument/2006/relationships">
   <p:cSld>
     <p:spTree>
@@ -25314,7 +25314,7 @@
 </p:sld>
 </file>
 
-<file path=ppt/slides/slide25.xml><?xml version="1.0" encoding="utf-8"?>
+<file path=ppt/slides/slide6.xml><?xml version="1.0" encoding="utf-8"?>
 <p:sld xmlns:a="http://schemas.openxmlformats.org/drawingml/2006/main" xmlns:p="http://schemas.openxmlformats.org/presentationml/2006/main" xmlns:r="http://schemas.openxmlformats.org/officeDocument/2006/relationships">
   <p:cSld>
     <p:spTree>

</xml_diff>